<commit_message>
docs(semana5): calibrar presentacion PPTX, slides y speech al formato oficial de 7 minutos (3m pitch + 2m demo + 2m Q&A)
</commit_message>
<xml_diff>
--- a/docs/semana5/Authory_Demo_Day_Stellar.pptx
+++ b/docs/semana5/Authory_Demo_Day_Stellar.pptx
@@ -13,6 +13,7 @@
     <p:sldId id="261" r:id="rId13"/>
     <p:sldId id="262" r:id="rId14"/>
     <p:sldId id="263" r:id="rId15"/>
+    <p:sldId id="264" r:id="rId16"/>
   </p:sldIdLst>
   <p:sldSz cx="12191695" cy="6858000" type="screen4x3"/>
   <p:notesSz cx="6858000" cy="9144000"/>
@@ -515,29 +516,29 @@
           <a:p/>
           <a:p>
             <a:r>
-              <a:t>«Buenas tardes a todos. Mi nombre es [Tu Nombre], y hoy venimos a presentarles Authory: la infraestructura sobre la red Stellar para que los creadores independientes certifiquen su autoría y comercialicen sus derechos con total certeza.»</a:t>
+              <a:t>«Buenas tardes a todos, miembros del jurado y comunidad. Somos el equipo de Authory, proyecto finalista de México, y hoy venimos a presentarles la infraestructura sobre la red Stellar para que los creadores independientes certifiquen su autoría y comercialicen sus derechos con total certeza.»</a:t>
             </a:r>
           </a:p>
           <a:p/>
           <a:p>
             <a:r>
-              <a:t>=== NOTAS TÉCNICAS Y OPERATIVAS ===</a:t>
+              <a:t>=== PAUTAS OPERATIVAS &amp; PLAN B ===</a:t>
             </a:r>
           </a:p>
           <a:p/>
           <a:p>
             <a:r>
-              <a:t>PANTALLA: Portada institucional con look &amp; feel brutalista.</a:t>
-            </a:r>
-          </a:p>
-          <a:p>
-            <a:r>
-              <a:t>DRIVER: Comprueba pantalla completa, volumen y tiene la demo lista en otra pestaña.</a:t>
-            </a:r>
-          </a:p>
-          <a:p>
-            <a:r>
-              <a:t>PLAN B: Si el proyector falla, recargar.</a:t>
+              <a:t>PANTALLA: Portada institucional.</a:t>
+            </a:r>
+          </a:p>
+          <a:p>
+            <a:r>
+              <a:t>LOGÍSTICA: Cámaras encendidas, micrófono probado.</a:t>
+            </a:r>
+          </a:p>
+          <a:p>
+            <a:r>
+              <a:t>DRIVER: Pantalla en foco con demo lista en otra pestaña.</a:t>
             </a:r>
           </a:p>
         </p:txBody>
@@ -613,19 +614,19 @@
           <a:p/>
           <a:p>
             <a:r>
-              <a:t>«Les presento a Mateo. Mateo es un ilustrador independiente en Medellín. Hace tres meses invirtió semanas creando un set de personajes para una agencia. Entregó bocetos por correo y, cuando cancelaron el encargo aduciendo recorte de presupuesto, vio sus ilustraciones en vallas publicitarias sin su firma y sin un peso de regalías.</a:t>
+              <a:t>«Les presento a Mateo. Mateo es un ilustrador independiente. Hace tres meses, invirtió semanas creando una serie de personajes para una agencia comercial. Entregó bocetos por correo, compartió carpetas en la nube y, cuando el proyecto se canceló supuestamente 'por presupuesto', vio sus ilustraciones impresas en vallas publicitarias sin su crédito y sin un solo centavo de pago.</a:t>
             </a:r>
           </a:p>
           <a:p/>
           <a:p>
             <a:r>
-              <a:t>El caso de Mateo no es aislado: según la Freelancers Union, más del 71% de los creadores independientes sufren impago o plagio. ¿Por qué no reclaman? Porque hoy sus únicas pruebas son fechas locales de archivos o cadenas de correos que cualquier peritaje descarta. Reclamar cuesta más que el proyecto.»</a:t>
+              <a:t>El caso de Mateo no es un accidente aislado: según la Freelancers Union y la OMPI, más del 71% de los creadores independientes han sufrido apropiación o impago de sus trabajos. ¿Por qué no reclaman? Porque hoy sus únicas pruebas son fechas locales de Photoshop o cadenas de correo que cualquier peritaje puede descartar. Reclamar cuesta más dinero y tiempo que lo que vale el proyecto.»</a:t>
             </a:r>
           </a:p>
           <a:p/>
           <a:p>
             <a:r>
-              <a:t>=== NOTAS TÉCNICAS Y OPERATIVAS ===</a:t>
+              <a:t>=== PAUTAS OPERATIVAS &amp; PLAN B ===</a:t>
             </a:r>
           </a:p>
           <a:p/>
@@ -636,12 +637,7 @@
           </a:p>
           <a:p>
             <a:r>
-              <a:t>DRIVER: Mira al público, atento al ritmo del narrador.</a:t>
-            </a:r>
-          </a:p>
-          <a:p>
-            <a:r>
-              <a:t>PLAN B: Fuente verificable: Reporte WIPO y Freelancers Union 2024.</a:t>
+              <a:t>DRIVER: Contacto visual con la cámara, atento al ritmo.</a:t>
             </a:r>
           </a:p>
         </p:txBody>
@@ -717,13 +713,13 @@
           <a:p/>
           <a:p>
             <a:r>
-              <a:t>«Aquí intervienen dos partes con una fricción mutua: Mateo necesita una prueba de existencia inmutable desde el minuto cero; y del otro lado, las editoriales y compradores honestos necesitan comprobar en cinco segundos que quien les ofrece una obra tiene la titularidad legítima para licenciarla, sin tener que esperar semanas de trámites notariales.»</a:t>
+              <a:t>«Aquí intervienen dos partes con una fricción mutua: Mateo necesita una prueba de existencia inmutable desde el minuto cero; y del otro lado, las editoriales y compradores honestos necesitan comprobar que quien les vende una obra realmente tiene la titularidad legítima para licenciarla, sin tener que esperar semanas de trámites notariales.»</a:t>
             </a:r>
           </a:p>
           <a:p/>
           <a:p>
             <a:r>
-              <a:t>=== NOTAS TÉCNICAS Y OPERATIVAS ===</a:t>
+              <a:t>=== PAUTAS OPERATIVAS &amp; PLAN B ===</a:t>
             </a:r>
           </a:p>
           <a:p/>
@@ -734,12 +730,7 @@
           </a:p>
           <a:p>
             <a:r>
-              <a:t>DRIVER: Confirma que la pestaña de la demo esté lista en `authority-khaki.vercel.app`.</a:t>
-            </a:r>
-          </a:p>
-          <a:p>
-            <a:r>
-              <a:t>PLAN B: Tener `localhost:3000` listo por si falla la conexión wifi.</a:t>
+              <a:t>DRIVER: Comprueba pestaña de Vercel lista en `authority-khaki.vercel.app`.</a:t>
             </a:r>
           </a:p>
         </p:txBody>
@@ -826,35 +817,24 @@
           <a:p/>
           <a:p>
             <a:r>
-              <a:t>Y aquí surge la pregunta inevitable: ¿Por qué blockchain y no una base de datos normal? Porque en una base de datos tradicional la confianza depende del administrador. En la red Stellar, el sello queda anclado en un ledger distribuido que ninguna de las partes puede alterar y que cualquiera puede auditar sin pedir permiso.</a:t>
+              <a:t>La audiencia y el jurado se preguntarán: ¿Por qué blockchain y no una base de datos normal? Porque si almacenamos esto en una base de datos tradicional, la confianza depende del administrador. Si la empresa quiebra o altera un registro, la prueba muere. En la red Stellar, el sello queda anclado en un ledger distribuido que ninguna de las partes puede modificar y que cualquier persona puede verificar de por vida de forma independiente.»</a:t>
             </a:r>
           </a:p>
           <a:p/>
           <a:p>
             <a:r>
-              <a:t>Veamos exactamente cómo lo hace Mateo en Authory...»</a:t>
+              <a:t>=== PAUTAS OPERATIVAS &amp; PLAN B ===</a:t>
             </a:r>
           </a:p>
           <a:p/>
           <a:p>
             <a:r>
-              <a:t>=== NOTAS TÉCNICAS Y OPERATIVAS ===</a:t>
-            </a:r>
-          </a:p>
-          <a:p/>
-          <a:p>
-            <a:r>
-              <a:t>PANTALLA: Fórmula de valor y recuadro '¿Por qué Blockchain?'.</a:t>
+              <a:t>PANTALLA: Fórmula de valor y recuadro de Blockchain.</a:t>
             </a:r>
           </a:p>
           <a:p>
             <a:r>
               <a:t>DRIVER: Prepara la ventana de navegación en `/registrar-obra`.</a:t>
-            </a:r>
-          </a:p>
-          <a:p>
-            <a:r>
-              <a:t>PLAN B: Transición verbal fluida hacia la demo.</a:t>
             </a:r>
           </a:p>
         </p:txBody>
@@ -930,36 +910,29 @@
           <a:p/>
           <a:p>
             <a:r>
-              <a:t>«(El driver comparte pantalla en Vercel) Mateo entra a Authory y selecciona su archivo. En este milisegundo, el navegador ejecuta un cálculo criptográfico SHA-256 en su memoria local. Noten esto: el arte de Mateo no viaja por internet, su privacidad sigue intacta.</a:t>
+              <a:t>«¿Cómo comprueba cualquier persona en el mundo que esto no es un truco de interfaz? Aquí está el registro en la red pública de Stellar.</a:t>
+            </a:r>
+          </a:p>
+          <a:p>
+            <a:r>
+              <a:t>Nuestro contrato inteligente está desplegado en Soroban Testnet con la dirección CAOAFGP... Tenemos transacciones reales emitidas en vivo como 725e12..., el código fuente está abierto y documentado en nuestro repositorio con guías de reproducción paso a paso, y la aplicación está desplegada y accesible hoy mismo en Vercel.»</a:t>
             </a:r>
           </a:p>
           <a:p/>
           <a:p>
             <a:r>
-              <a:t>Al confirmar, Authory invoca nuestro contrato inteligente en Soroban Testnet. La red procesa la transacción y emite un evento inmutable con la estampa de tiempo del bloque.</a:t>
+              <a:t>=== PAUTAS OPERATIVAS &amp; PLAN B ===</a:t>
             </a:r>
           </a:p>
           <a:p/>
           <a:p>
             <a:r>
-              <a:t>(Driver pasa a /verificar) Ahora somos la editorial. Llega el comprador a la pantalla de verificación pública y sube el archivo recibido. En menos de 3 segundos, Authory consulta la red: comprueba que el hash coincide exactamente con el registrado por Mateo y muestra su historial. La editorial tiene la certeza de contratar con el autor legítimo, y Mateo tiene una prueba irrefutable respaldándolo.»</a:t>
-            </a:r>
-          </a:p>
-          <a:p/>
-          <a:p>
-            <a:r>
-              <a:t>=== NOTAS TÉCNICAS Y OPERATIVAS ===</a:t>
-            </a:r>
-          </a:p>
-          <a:p/>
-          <a:p>
-            <a:r>
-              <a:t>DRIVER: Ejecuta en silencio y con calma. No habla. Deja que el orador narre resultados.</a:t>
-            </a:r>
-          </a:p>
-          <a:p>
-            <a:r>
-              <a:t>PLAN B: Si Soroban tarda &gt;15s, switch inmediato al video de YouTube (minuto 1:15) en pestaña oculta.</a:t>
+              <a:t>PANTALLA: Hashes y enlaces de verificación en Stellar Expert.</a:t>
+            </a:r>
+          </a:p>
+          <a:p>
+            <a:r>
+              <a:t>DRIVER: En foco.</a:t>
             </a:r>
           </a:p>
         </p:txBody>
@@ -1035,34 +1008,30 @@
           <a:p/>
           <a:p>
             <a:r>
-              <a:t>«¿Cómo comprueba cualquier persona en el mundo que esto no es un truco de interfaz? Aquí está el registro en la red pública de Stellar.</a:t>
-            </a:r>
-          </a:p>
-          <a:p>
-            <a:r>
-              <a:t>Nuestro contrato inteligente está desplegado en Soroban Testnet con la dirección CAOAFGP... Tenemos transacciones reales emitidas en vivo como 725e12..., el código fuente está abierto y documentado en nuestro repositorio con guías de reproducción paso a paso, y la aplicación está desplegada y accesible hoy mismo en Vercel.»</a:t>
+              <a:t>«Durante estas semanas aprendimos algo fundamental: la tecnología no sirve si genera fricción. En nuestras primeras pruebas descubrimos que exigirle al creador conectar una billetera con saldo de gas antes de registrar su primer dibujo hacía que el 80% abandonara. Por eso rediseñamos la experiencia: generamos el cálculo criptográfico en el cliente y la evidencia de forma transparente.</a:t>
             </a:r>
           </a:p>
           <a:p/>
           <a:p>
             <a:r>
-              <a:t>=== NOTAS TÉCNICAS Y OPERATIVAS ===</a:t>
+              <a:t>Lo que observamos es que el creador busca simplicidad; lo que comprobamos es que el contrato ejecuta las atestaciones en menos de 3 segundos; y lo que vamos a validar con nuestro protocolo de 10 usuarios es que 4 de cada 5 incluirán este sello en sus cotizaciones comerciales.»</a:t>
             </a:r>
           </a:p>
           <a:p/>
           <a:p>
             <a:r>
-              <a:t>PANTALLA: Hashes y enlaces de verificación en Stellar Expert.</a:t>
-            </a:r>
-          </a:p>
-          <a:p>
-            <a:r>
-              <a:t>DRIVER: Si hay 5 segundos de sobra, muestra la pestaña de Stellar Expert con el evento emitido.</a:t>
-            </a:r>
-          </a:p>
-          <a:p>
-            <a:r>
-              <a:t>PLAN B: El enlace y QR están en pantalla para que el jurado lo audite.</a:t>
+              <a:t>=== PAUTAS OPERATIVAS &amp; PLAN B ===</a:t>
+            </a:r>
+          </a:p>
+          <a:p/>
+          <a:p>
+            <a:r>
+              <a:t>PANTALLA: Las 3 columnas de validación.</a:t>
+            </a:r>
+          </a:p>
+          <a:p>
+            <a:r>
+              <a:t>DRIVER: Prepara la pantalla compartida de la demo.</a:t>
             </a:r>
           </a:p>
         </p:txBody>
@@ -1138,35 +1107,41 @@
           <a:p/>
           <a:p>
             <a:r>
-              <a:t>«Durante estas semanas aprendimos que la tecnología no sirve si genera fricción. En nuestras primeras pruebas descubrimos que exigirle al creador conectar una billetera con saldo de gas antes de registrar su primer dibujo hacía que el 80% abandonara. Por eso rediseñamos la experiencia: generamos el cálculo en el cliente y la evidencia de forma transparente.</a:t>
+              <a:t>«Lo que sigue en los próximos 30 días es integrar Stellar Wallets Kit para firma descentralizada nativa y lanzar nuestro primer piloto con comunidades creativas.</a:t>
             </a:r>
           </a:p>
           <a:p/>
           <a:p>
             <a:r>
-              <a:t>Lo que observamos es que el creador busca simplicidad; lo que comprobamos es que el contrato ejecuta las atestaciones en menos de 3 segundos; y lo que vamos a validar con nuestro protocolo de 10 usuarios es que 4 de cada 5 incluirán este sello en sus cotizaciones comerciales.»</a:t>
+              <a:t>Por eso, hoy venimos a hacerles un pedido concreto:</a:t>
+            </a:r>
+          </a:p>
+          <a:p>
+            <a:r>
+              <a:t>Buscamos 5 agencias creativas y 10 creadores independientes que quieran proteger y certificar sus próximas 3 entregas con Authory.</a:t>
             </a:r>
           </a:p>
           <a:p/>
           <a:p>
             <a:r>
-              <a:t>=== NOTAS TÉCNICAS Y OPERATIVAS ===</a:t>
+              <a:t>Y para ver exactamente cómo lo vive Mateo en tiempo real, pasemos a nuestra demostración en vivo.»</a:t>
             </a:r>
           </a:p>
           <a:p/>
           <a:p>
             <a:r>
-              <a:t>PANTALLA: Las 3 columnas de validación.</a:t>
-            </a:r>
-          </a:p>
-          <a:p>
-            <a:r>
-              <a:t>DRIVER: Vuelve a enfocar las diapositivas.</a:t>
-            </a:r>
-          </a:p>
-          <a:p>
-            <a:r>
-              <a:t>PLAN B: Tono de honestidad técnica recomendado en el bootcamp.</a:t>
+              <a:t>=== PAUTAS OPERATIVAS &amp; PLAN B ===</a:t>
+            </a:r>
+          </a:p>
+          <a:p/>
+          <a:p>
+            <a:r>
+              <a:t>DRIVER: Cambia inmediatamente a pantalla compartida del navegador en Vercel.</a:t>
+            </a:r>
+          </a:p>
+          <a:p>
+            <a:r>
+              <a:t>TIMEKEEPER: Marca el inicio del cronómetro de 2 minutos de Demo.</a:t>
             </a:r>
           </a:p>
         </p:txBody>
@@ -1242,47 +1217,161 @@
           <a:p/>
           <a:p>
             <a:r>
-              <a:t>«Lo que sigue en los próximos 30 días es integrar Stellar Wallets Kit para firma descentralizada nativa y lanzar nuestro primer piloto con comunidades creativas.</a:t>
+              <a:t>«(Driver en /registrar-obra) Vamos a ponernos en los zapatos de Mateo. Acaba de terminar su ilustración y necesita protegerla antes de enviarla a la agencia. Al seleccionarla, la Web Crypto API en su navegador calcula instantáneamente la huella digital matemática de la obra. Noten algo crucial: el archivo original jamás viaja por internet; su arte sigue siendo 100% privado en su máquina.</a:t>
             </a:r>
           </a:p>
           <a:p/>
           <a:p>
             <a:r>
-              <a:t>Por eso, hoy no venimos a decirles 'gracias, ¿alguna pregunta?'. Hoy venimos a hacerles un pedido concreto:</a:t>
+              <a:t>(Driver hace clic en Crear evidencia) En este momento, Authory invoca nuestro contrato inteligente en Soroban Testnet. La red estampa de manera inalterable la huella digital y la fecha en el ledger de Stellar, emitiendo el evento nativo de registro. Mateo ya tiene su evidencia de autoría legalmente auditable.</a:t>
             </a:r>
           </a:p>
           <a:p/>
           <a:p>
             <a:r>
-              <a:t>Buscamos 5 agencias creativas y 10 creadores independientes que quieran proteger y certificar sus próximas 3 entregas con Authory.</a:t>
+              <a:t>(Driver pasa a /verificar) Ahora cambiamos de rol y nos ponemos en el lugar de la editorial. Llega el comprador a la pantalla de verificación pública y, sin necesidad de crear cuenta, contraseñas ni pedirle permiso a Mateo, sube el archivo recibido. En menos de 3 segundos, Authory contrasta los bytes contra Stellar: confirma que el arte es original de Mateo, que la fecha precede a la campaña y que no ha sido alterado ni un solo pixel.</a:t>
             </a:r>
           </a:p>
           <a:p/>
           <a:p>
             <a:r>
-              <a:t>Ayúdennos a que ningún Mateo vuelva a perder los derechos sobre su propia obra. Muchas gracias.»</a:t>
+              <a:t>(Driver muestra Stellar Expert) ¿Y cómo sabe la editorial que esto no es un truco de nuestra aplicación? Porque aquí está la transacción en el explorador oficial de Stellar Expert: el contrato CAOAFGP... registró la huella de forma pública e inalterable. Esta es la certeza técnica que Authory le devuelve a los creadores. Quedamos a disposición del jurado para sus preguntas.»</a:t>
             </a:r>
           </a:p>
           <a:p/>
           <a:p>
             <a:r>
-              <a:t>=== NOTAS TÉCNICAS Y OPERATIVAS ===</a:t>
+              <a:t>=== PAUTAS OPERATIVAS &amp; PLAN B ===</a:t>
             </a:r>
           </a:p>
           <a:p/>
           <a:p>
             <a:r>
-              <a:t>PANTALLA: Mateo seguro con su obra y pedido concreto.</a:t>
-            </a:r>
-          </a:p>
-          <a:p>
-            <a:r>
-              <a:t>DRIVER: Deja visible el slide de cierre con el repositorio.</a:t>
-            </a:r>
-          </a:p>
-          <a:p>
-            <a:r>
-              <a:t>PLAN B: Cierre firme y con impacto sin vacilar.</a:t>
+              <a:t>DRIVER: Ejecuta sin hablar y con movimientos limpios.</a:t>
+            </a:r>
+          </a:p>
+          <a:p>
+            <a:r>
+              <a:t>ORADOR: Mantiene el ritmo y proyecta la voz.</a:t>
+            </a:r>
+          </a:p>
+          <a:p>
+            <a:r>
+              <a:t>TIMEKEEPER: Al minuto 4:45 dar señal para cerrar demo y pasar a Q&amp;A.</a:t>
+            </a:r>
+          </a:p>
+        </p:txBody>
+      </p:sp>
+      <p:sp>
+        <p:nvSpPr>
+          <p:cNvPr id="4" name="Slide Number Placeholder 3"/>
+          <p:cNvSpPr>
+            <a:spLocks noGrp="1"/>
+          </p:cNvSpPr>
+          <p:nvPr>
+            <p:ph type="sldNum" idx="5" sz="quarter"/>
+          </p:nvPr>
+        </p:nvSpPr>
+        <p:spPr/>
+      </p:sp>
+    </p:spTree>
+  </p:cSld>
+  <p:clrMapOvr>
+    <a:masterClrMapping/>
+  </p:clrMapOvr>
+</p:notes>
+</file>
+
+<file path=ppt/notesSlides/notesSlide9.xml><?xml version="1.0" encoding="utf-8"?>
+<p:notes xmlns:a="http://schemas.openxmlformats.org/drawingml/2006/main" xmlns:p="http://schemas.openxmlformats.org/presentationml/2006/main" xmlns:r="http://schemas.openxmlformats.org/officeDocument/2006/relationships">
+  <p:cSld>
+    <p:spTree>
+      <p:nvGrpSpPr>
+        <p:cNvPr id="1" name=""/>
+        <p:cNvGrpSpPr/>
+        <p:nvPr/>
+      </p:nvGrpSpPr>
+      <p:grpSpPr>
+        <a:xfrm>
+          <a:off x="0" y="0"/>
+          <a:ext cx="0" cy="0"/>
+          <a:chOff x="0" y="0"/>
+          <a:chExt cx="0" cy="0"/>
+        </a:xfrm>
+      </p:grpSpPr>
+      <p:sp>
+        <p:nvSpPr>
+          <p:cNvPr id="2" name="Slide Image Placeholder 1"/>
+          <p:cNvSpPr>
+            <a:spLocks noGrp="1"/>
+          </p:cNvSpPr>
+          <p:nvPr>
+            <p:ph type="sldImg" idx="2"/>
+          </p:nvPr>
+        </p:nvSpPr>
+        <p:spPr/>
+      </p:sp>
+      <p:sp>
+        <p:nvSpPr>
+          <p:cNvPr id="3" name="Notes Placeholder 2"/>
+          <p:cNvSpPr>
+            <a:spLocks noGrp="1"/>
+          </p:cNvSpPr>
+          <p:nvPr>
+            <p:ph type="body" idx="3" sz="quarter"/>
+          </p:nvPr>
+        </p:nvSpPr>
+        <p:spPr/>
+        <p:txBody>
+          <a:bodyPr/>
+          <a:lstStyle/>
+          <a:p>
+            <a:r>
+              <a:t>=== SPEECH DEL ORADOR ===</a:t>
+            </a:r>
+          </a:p>
+          <a:p/>
+          <a:p>
+            <a:r>
+              <a:t>«El equipo está listo para responder las preguntas del jurado.</a:t>
+            </a:r>
+          </a:p>
+          <a:p/>
+          <a:p>
+            <a:r>
+              <a:t>Recordatorios clave:</a:t>
+            </a:r>
+          </a:p>
+          <a:p>
+            <a:r>
+              <a:t>• Si preguntan por qué no Postgres: Responder sobre neutralidad probatoria e inmutabilidad.</a:t>
+            </a:r>
+          </a:p>
+          <a:p>
+            <a:r>
+              <a:t>• Si preguntan por fraude previo: Responder que la blockchain garantiza precedencia temporal matemática, no verdad física.</a:t>
+            </a:r>
+          </a:p>
+          <a:p>
+            <a:r>
+              <a:t>• Si preguntan por gas/comisiones: Indicar que cuesta menos de $0.001 USD y que se patrocina en onboarding.</a:t>
+            </a:r>
+          </a:p>
+          <a:p>
+            <a:r>
+              <a:t>• Si preguntan por privacidad: Enfatizar que el archivo original nunca toca la blockchain ni viaja por internet.»</a:t>
+            </a:r>
+          </a:p>
+          <a:p/>
+          <a:p>
+            <a:r>
+              <a:t>=== PAUTAS OPERATIVAS &amp; PLAN B ===</a:t>
+            </a:r>
+          </a:p>
+          <a:p/>
+          <a:p>
+            <a:r>
+              <a:t>JURADO: Respuestas de máximo 35 segundos para permitir 2 a 3 preguntas completas.</a:t>
             </a:r>
           </a:p>
         </p:txBody>
@@ -4341,7 +4430,7 @@
         </p:nvSpPr>
         <p:spPr>
           <a:xfrm>
-            <a:off x="731520" y="457200"/>
+            <a:off x="731520" y="411480"/>
             <a:ext cx="10698480" cy="365760"/>
           </a:xfrm>
           <a:prstGeom prst="rect">
@@ -4364,7 +4453,7 @@
               </a:defRPr>
             </a:pPr>
             <a:r>
-              <a:t>BLOCKCHAIN BUILDERS 101 · SESIÓN #9 · DEMOSTRAR</a:t>
+              <a:t>BLOCKCHAIN BUILDERS 101 · PROYECTO FINALISTA #1 DE MÉXICO · STELLAR × BAF</a:t>
             </a:r>
           </a:p>
         </p:txBody>
@@ -4377,7 +4466,7 @@
         </p:nvSpPr>
         <p:spPr>
           <a:xfrm>
-            <a:off x="731520" y="822960"/>
+            <a:off x="731520" y="777240"/>
             <a:ext cx="10698480" cy="822960"/>
           </a:xfrm>
           <a:prstGeom prst="rect">
@@ -4392,7 +4481,7 @@
           <a:lstStyle/>
           <a:p>
             <a:pPr>
-              <a:defRPr sz="2800" b="1">
+              <a:defRPr sz="2700" b="1">
                 <a:solidFill>
                   <a:srgbClr val="F0F7FB"/>
                 </a:solidFill>
@@ -4429,8 +4518,8 @@
         </p:nvSpPr>
         <p:spPr>
           <a:xfrm>
-            <a:off x="731520" y="1828800"/>
-            <a:ext cx="6035040" cy="4114800"/>
+            <a:off x="731520" y="1783080"/>
+            <a:ext cx="6035040" cy="4160520"/>
           </a:xfrm>
           <a:prstGeom prst="rect">
             <a:avLst/>
@@ -4474,8 +4563,8 @@
         </p:nvSpPr>
         <p:spPr>
           <a:xfrm>
-            <a:off x="1005840" y="2103120"/>
-            <a:ext cx="5486400" cy="3566160"/>
+            <a:off x="1005840" y="2011680"/>
+            <a:ext cx="5486400" cy="3657600"/>
           </a:xfrm>
           <a:prstGeom prst="rect">
             <a:avLst/>
@@ -4558,8 +4647,8 @@
         </p:nvSpPr>
         <p:spPr>
           <a:xfrm>
-            <a:off x="7040880" y="1828800"/>
-            <a:ext cx="4389120" cy="4114800"/>
+            <a:off x="7040880" y="1783080"/>
+            <a:ext cx="4389120" cy="4160520"/>
           </a:xfrm>
           <a:prstGeom prst="rect">
             <a:avLst/>
@@ -4603,8 +4692,8 @@
         </p:nvSpPr>
         <p:spPr>
           <a:xfrm>
-            <a:off x="7315200" y="2103120"/>
-            <a:ext cx="3840480" cy="3566160"/>
+            <a:off x="7315200" y="2011680"/>
+            <a:ext cx="3840480" cy="3657600"/>
           </a:xfrm>
           <a:prstGeom prst="rect">
             <a:avLst/>
@@ -4739,7 +4828,7 @@
         </p:nvSpPr>
         <p:spPr>
           <a:xfrm>
-            <a:off x="731520" y="6217920"/>
+            <a:off x="731520" y="6236208"/>
             <a:ext cx="10728655" cy="18288"/>
           </a:xfrm>
           <a:prstGeom prst="rect">
@@ -4784,7 +4873,7 @@
         </p:nvSpPr>
         <p:spPr>
           <a:xfrm>
-            <a:off x="731520" y="6291072"/>
+            <a:off x="731520" y="6309360"/>
             <a:ext cx="7772400" cy="320040"/>
           </a:xfrm>
           <a:prstGeom prst="rect">
@@ -4807,7 +4896,7 @@
               </a:defRPr>
             </a:pPr>
             <a:r>
-              <a:t>Stellar × BAF · Demo Day Bootcamp Blockchain Builders</a:t>
+              <a:t>Bloque 1: Presentación (3:00 min) · Finalista #1 México</a:t>
             </a:r>
           </a:p>
         </p:txBody>
@@ -4820,7 +4909,7 @@
         </p:nvSpPr>
         <p:spPr>
           <a:xfrm>
-            <a:off x="8686800" y="6291072"/>
+            <a:off x="8686800" y="6309360"/>
             <a:ext cx="2773375" cy="320040"/>
           </a:xfrm>
           <a:prstGeom prst="rect">
@@ -4919,7 +5008,7 @@
         </p:nvSpPr>
         <p:spPr>
           <a:xfrm>
-            <a:off x="731520" y="457200"/>
+            <a:off x="731520" y="411480"/>
             <a:ext cx="10698480" cy="365760"/>
           </a:xfrm>
           <a:prstGeom prst="rect">
@@ -4955,7 +5044,7 @@
         </p:nvSpPr>
         <p:spPr>
           <a:xfrm>
-            <a:off x="731520" y="822960"/>
+            <a:off x="731520" y="777240"/>
             <a:ext cx="10698480" cy="822960"/>
           </a:xfrm>
           <a:prstGeom prst="rect">
@@ -4970,7 +5059,7 @@
           <a:lstStyle/>
           <a:p>
             <a:pPr>
-              <a:defRPr sz="2800" b="1">
+              <a:defRPr sz="2700" b="1">
                 <a:solidFill>
                   <a:srgbClr val="F0F7FB"/>
                 </a:solidFill>
@@ -5004,8 +5093,8 @@
         </p:nvSpPr>
         <p:spPr>
           <a:xfrm>
-            <a:off x="731520" y="1828800"/>
-            <a:ext cx="5486400" cy="4114800"/>
+            <a:off x="731520" y="1783080"/>
+            <a:ext cx="5486400" cy="4160520"/>
           </a:xfrm>
           <a:prstGeom prst="rect">
             <a:avLst/>
@@ -5049,8 +5138,8 @@
         </p:nvSpPr>
         <p:spPr>
           <a:xfrm>
-            <a:off x="1005840" y="2103120"/>
-            <a:ext cx="4937760" cy="3566160"/>
+            <a:off x="1005840" y="2011680"/>
+            <a:ext cx="4937760" cy="3657600"/>
           </a:xfrm>
           <a:prstGeom prst="rect">
             <a:avLst/>
@@ -5088,7 +5177,7 @@
               </a:defRPr>
             </a:pPr>
             <a:r>
-              <a:t>Mateo, ilustrador independiente en Medellín</a:t>
+              <a:t>Mateo, ilustrador independiente en CDMX / Medellín</a:t>
             </a:r>
           </a:p>
           <a:p>
@@ -5104,7 +5193,7 @@
               </a:defRPr>
             </a:pPr>
             <a:r>
-              <a:t>Mateo invirtió semanas creando una serie de personajes para una agencia publicitaria. Entregó bocetos por correo y el cliente canceló el encargo aduciendo 'recorte de presupuesto'.</a:t>
+              <a:t>Mateo invirtió semanas creando una serie de personajes para una agencia comercial. Entregó bocetos por correo y el cliente canceló el encargo aduciendo 'recorte de presupuesto'.</a:t>
             </a:r>
           </a:p>
           <a:p>
@@ -5133,8 +5222,8 @@
         </p:nvSpPr>
         <p:spPr>
           <a:xfrm>
-            <a:off x="6492240" y="1828800"/>
-            <a:ext cx="4937760" cy="4114800"/>
+            <a:off x="6492240" y="1783080"/>
+            <a:ext cx="4937760" cy="4160520"/>
           </a:xfrm>
           <a:prstGeom prst="rect">
             <a:avLst/>
@@ -5178,8 +5267,8 @@
         </p:nvSpPr>
         <p:spPr>
           <a:xfrm>
-            <a:off x="6766560" y="2103120"/>
-            <a:ext cx="4389120" cy="3566160"/>
+            <a:off x="6766560" y="2011680"/>
+            <a:ext cx="4389120" cy="3657600"/>
           </a:xfrm>
           <a:prstGeom prst="rect">
             <a:avLst/>
@@ -5248,7 +5337,7 @@
             <a:br/>
             <a:br/>
             <a:r>
-              <a:t>¿Por qué no reclaman? Porque hoy sus únicas pruebas son fechas locales de archivos o cadenas de correo. Cualquier peritaje judicial cuesta más que el encargo mismo.</a:t>
+              <a:t>¿Por qué no reclaman? Porque hoy sus únicas pruebas son fechas locales de archivos o cadenas de correo. Cualquier peritaje judicial cuesta más dinero que el encargo mismo.</a:t>
             </a:r>
           </a:p>
         </p:txBody>
@@ -5261,7 +5350,7 @@
         </p:nvSpPr>
         <p:spPr>
           <a:xfrm>
-            <a:off x="731520" y="6217920"/>
+            <a:off x="731520" y="6236208"/>
             <a:ext cx="10728655" cy="18288"/>
           </a:xfrm>
           <a:prstGeom prst="rect">
@@ -5306,7 +5395,7 @@
         </p:nvSpPr>
         <p:spPr>
           <a:xfrm>
-            <a:off x="731520" y="6291072"/>
+            <a:off x="731520" y="6309360"/>
             <a:ext cx="7772400" cy="320040"/>
           </a:xfrm>
           <a:prstGeom prst="rect">
@@ -5342,7 +5431,7 @@
         </p:nvSpPr>
         <p:spPr>
           <a:xfrm>
-            <a:off x="8686800" y="6291072"/>
+            <a:off x="8686800" y="6309360"/>
             <a:ext cx="2773375" cy="320040"/>
           </a:xfrm>
           <a:prstGeom prst="rect">
@@ -5365,7 +5454,7 @@
               </a:defRPr>
             </a:pPr>
             <a:r>
-              <a:t>0:15 - 0:45 (30 s)</a:t>
+              <a:t>0:15 - 0:50 (35 s)</a:t>
             </a:r>
           </a:p>
         </p:txBody>
@@ -5441,7 +5530,7 @@
         </p:nvSpPr>
         <p:spPr>
           <a:xfrm>
-            <a:off x="731520" y="457200"/>
+            <a:off x="731520" y="411480"/>
             <a:ext cx="10698480" cy="365760"/>
           </a:xfrm>
           <a:prstGeom prst="rect">
@@ -5477,7 +5566,7 @@
         </p:nvSpPr>
         <p:spPr>
           <a:xfrm>
-            <a:off x="731520" y="822960"/>
+            <a:off x="731520" y="777240"/>
             <a:ext cx="10698480" cy="822960"/>
           </a:xfrm>
           <a:prstGeom prst="rect">
@@ -5492,7 +5581,7 @@
           <a:lstStyle/>
           <a:p>
             <a:pPr>
-              <a:defRPr sz="2800" b="1">
+              <a:defRPr sz="2700" b="1">
                 <a:solidFill>
                   <a:srgbClr val="F0F7FB"/>
                 </a:solidFill>
@@ -5521,8 +5610,8 @@
         </p:nvSpPr>
         <p:spPr>
           <a:xfrm>
-            <a:off x="731520" y="1828800"/>
-            <a:ext cx="5212080" cy="4114800"/>
+            <a:off x="731520" y="1783080"/>
+            <a:ext cx="5212080" cy="4160520"/>
           </a:xfrm>
           <a:prstGeom prst="rect">
             <a:avLst/>
@@ -5566,8 +5655,8 @@
         </p:nvSpPr>
         <p:spPr>
           <a:xfrm>
-            <a:off x="1005840" y="2103120"/>
-            <a:ext cx="4663440" cy="3566160"/>
+            <a:off x="1005840" y="2011680"/>
+            <a:ext cx="4663440" cy="3657600"/>
           </a:xfrm>
           <a:prstGeom prst="rect">
             <a:avLst/>
@@ -5644,8 +5733,8 @@
         </p:nvSpPr>
         <p:spPr>
           <a:xfrm>
-            <a:off x="6217920" y="1828800"/>
-            <a:ext cx="5212080" cy="4114800"/>
+            <a:off x="6217920" y="1783080"/>
+            <a:ext cx="5212080" cy="4160520"/>
           </a:xfrm>
           <a:prstGeom prst="rect">
             <a:avLst/>
@@ -5689,8 +5778,8 @@
         </p:nvSpPr>
         <p:spPr>
           <a:xfrm>
-            <a:off x="6492240" y="2103120"/>
-            <a:ext cx="4663440" cy="3566160"/>
+            <a:off x="6492240" y="2011680"/>
+            <a:ext cx="4663440" cy="3657600"/>
           </a:xfrm>
           <a:prstGeom prst="rect">
             <a:avLst/>
@@ -5767,7 +5856,7 @@
         </p:nvSpPr>
         <p:spPr>
           <a:xfrm>
-            <a:off x="731520" y="6217920"/>
+            <a:off x="731520" y="6236208"/>
             <a:ext cx="10728655" cy="18288"/>
           </a:xfrm>
           <a:prstGeom prst="rect">
@@ -5812,7 +5901,7 @@
         </p:nvSpPr>
         <p:spPr>
           <a:xfrm>
-            <a:off x="731520" y="6291072"/>
+            <a:off x="731520" y="6309360"/>
             <a:ext cx="7772400" cy="320040"/>
           </a:xfrm>
           <a:prstGeom prst="rect">
@@ -5848,7 +5937,7 @@
         </p:nvSpPr>
         <p:spPr>
           <a:xfrm>
-            <a:off x="8686800" y="6291072"/>
+            <a:off x="8686800" y="6309360"/>
             <a:ext cx="2773375" cy="320040"/>
           </a:xfrm>
           <a:prstGeom prst="rect">
@@ -5871,7 +5960,7 @@
               </a:defRPr>
             </a:pPr>
             <a:r>
-              <a:t>0:45 - 1:10 (25 s)</a:t>
+              <a:t>0:50 - 1:20 (30 s)</a:t>
             </a:r>
           </a:p>
         </p:txBody>
@@ -5947,7 +6036,7 @@
         </p:nvSpPr>
         <p:spPr>
           <a:xfrm>
-            <a:off x="731520" y="457200"/>
+            <a:off x="731520" y="411480"/>
             <a:ext cx="10698480" cy="365760"/>
           </a:xfrm>
           <a:prstGeom prst="rect">
@@ -5983,7 +6072,7 @@
         </p:nvSpPr>
         <p:spPr>
           <a:xfrm>
-            <a:off x="731520" y="822960"/>
+            <a:off x="731520" y="777240"/>
             <a:ext cx="10698480" cy="822960"/>
           </a:xfrm>
           <a:prstGeom prst="rect">
@@ -5998,7 +6087,7 @@
           <a:lstStyle/>
           <a:p>
             <a:pPr>
-              <a:defRPr sz="2800" b="1">
+              <a:defRPr sz="2700" b="1">
                 <a:solidFill>
                   <a:srgbClr val="F0F7FB"/>
                 </a:solidFill>
@@ -6027,7 +6116,7 @@
         </p:nvSpPr>
         <p:spPr>
           <a:xfrm>
-            <a:off x="731520" y="1828800"/>
+            <a:off x="731520" y="1783080"/>
             <a:ext cx="10728655" cy="2286000"/>
           </a:xfrm>
           <a:prstGeom prst="rect">
@@ -6072,7 +6161,7 @@
         </p:nvSpPr>
         <p:spPr>
           <a:xfrm>
-            <a:off x="1005840" y="2011680"/>
+            <a:off x="1005840" y="1965960"/>
             <a:ext cx="10180015" cy="1920240"/>
           </a:xfrm>
           <a:prstGeom prst="rect">
@@ -6087,7 +6176,7 @@
           <a:lstStyle/>
           <a:p>
             <a:r>
-              <a:rPr b="1" sz="1400">
+              <a:rPr b="1" sz="1350">
                 <a:solidFill>
                   <a:srgbClr val="72E0ED"/>
                 </a:solidFill>
@@ -6096,7 +6185,7 @@
               <a:t>PARA:</a:t>
             </a:r>
             <a:r>
-              <a:rPr sz="1400">
+              <a:rPr sz="1350">
                 <a:solidFill>
                   <a:srgbClr val="F0F7FB"/>
                 </a:solidFill>
@@ -6108,11 +6197,11 @@
           <a:p>
             <a:pPr>
               <a:spcBef>
-                <a:spcPts val="600"/>
+                <a:spcPts val="500"/>
               </a:spcBef>
             </a:pPr>
             <a:r>
-              <a:rPr b="1" sz="1400">
+              <a:rPr b="1" sz="1350">
                 <a:solidFill>
                   <a:srgbClr val="72E0ED"/>
                 </a:solidFill>
@@ -6121,7 +6210,7 @@
               <a:t>QUE:</a:t>
             </a:r>
             <a:r>
-              <a:rPr sz="1400">
+              <a:rPr sz="1350">
                 <a:solidFill>
                   <a:srgbClr val="F0F7FB"/>
                 </a:solidFill>
@@ -6133,11 +6222,11 @@
           <a:p>
             <a:pPr>
               <a:spcBef>
-                <a:spcPts val="600"/>
+                <a:spcPts val="500"/>
               </a:spcBef>
             </a:pPr>
             <a:r>
-              <a:rPr b="1" sz="1400">
+              <a:rPr b="1" sz="1350">
                 <a:solidFill>
                   <a:srgbClr val="72E0ED"/>
                 </a:solidFill>
@@ -6146,23 +6235,23 @@
               <a:t>AUTHORY PERMITE:</a:t>
             </a:r>
             <a:r>
-              <a:rPr sz="1400">
+              <a:rPr sz="1350">
                 <a:solidFill>
                   <a:srgbClr val="F0F7FB"/>
                 </a:solidFill>
                 <a:latin typeface="IBM Plex Mono"/>
               </a:rPr>
-              <a:t> generar un sello temporal inmutable en Stellar manteniendo el archivo privado,</a:t>
+              <a:t> generar un pasaporte digital y un sello temporal inmutable en Stellar manteniendo el archivo privado,</a:t>
             </a:r>
           </a:p>
           <a:p>
             <a:pPr>
               <a:spcBef>
-                <a:spcPts val="600"/>
+                <a:spcPts val="500"/>
               </a:spcBef>
             </a:pPr>
             <a:r>
-              <a:rPr b="1" sz="1400">
+              <a:rPr b="1" sz="1350">
                 <a:solidFill>
                   <a:srgbClr val="72E0ED"/>
                 </a:solidFill>
@@ -6171,7 +6260,7 @@
               <a:t>A DIFERENCIA DE:</a:t>
             </a:r>
             <a:r>
-              <a:rPr sz="1400">
+              <a:rPr sz="1350">
                 <a:solidFill>
                   <a:srgbClr val="F0F7FB"/>
                 </a:solidFill>
@@ -6190,8 +6279,8 @@
         </p:nvSpPr>
         <p:spPr>
           <a:xfrm>
-            <a:off x="731520" y="4389120"/>
-            <a:ext cx="10728655" cy="1554480"/>
+            <a:off x="731520" y="4343400"/>
+            <a:ext cx="10728655" cy="1600200"/>
           </a:xfrm>
           <a:prstGeom prst="rect">
             <a:avLst/>
@@ -6235,8 +6324,8 @@
         </p:nvSpPr>
         <p:spPr>
           <a:xfrm>
-            <a:off x="1005840" y="4572000"/>
-            <a:ext cx="10180015" cy="1188720"/>
+            <a:off x="1005840" y="4526280"/>
+            <a:ext cx="10180015" cy="1234440"/>
           </a:xfrm>
           <a:prstGeom prst="rect">
             <a:avLst/>
@@ -6274,7 +6363,7 @@
               </a:defRPr>
             </a:pPr>
             <a:r>
-              <a:t>«Porque la huella queda en un registro público que ninguna de las partes puede alterar después y que cualquiera puede auditar sin pedir permiso.»</a:t>
+              <a:t>«Porque la huella queda en un registro público descentralizado que ninguna de las partes puede modificar después y que cualquiera puede auditar sin pedir permiso.»</a:t>
             </a:r>
           </a:p>
         </p:txBody>
@@ -6287,7 +6376,7 @@
         </p:nvSpPr>
         <p:spPr>
           <a:xfrm>
-            <a:off x="731520" y="6217920"/>
+            <a:off x="731520" y="6236208"/>
             <a:ext cx="10728655" cy="18288"/>
           </a:xfrm>
           <a:prstGeom prst="rect">
@@ -6332,7 +6421,7 @@
         </p:nvSpPr>
         <p:spPr>
           <a:xfrm>
-            <a:off x="731520" y="6291072"/>
+            <a:off x="731520" y="6309360"/>
             <a:ext cx="7772400" cy="320040"/>
           </a:xfrm>
           <a:prstGeom prst="rect">
@@ -6355,7 +6444,7 @@
               </a:defRPr>
             </a:pPr>
             <a:r>
-              <a:t>Frase que une: «Veamos exactamente cómo lo hace Mateo en Authory...»</a:t>
+              <a:t>Frase que une: «¿Cómo comprueba cualquier persona que esto no es una base de datos nuestra?...»</a:t>
             </a:r>
           </a:p>
         </p:txBody>
@@ -6368,7 +6457,7 @@
         </p:nvSpPr>
         <p:spPr>
           <a:xfrm>
-            <a:off x="8686800" y="6291072"/>
+            <a:off x="8686800" y="6309360"/>
             <a:ext cx="2773375" cy="320040"/>
           </a:xfrm>
           <a:prstGeom prst="rect">
@@ -6391,7 +6480,7 @@
               </a:defRPr>
             </a:pPr>
             <a:r>
-              <a:t>1:10 - 1:40 (30 s)</a:t>
+              <a:t>1:20 - 1:55 (35 s)</a:t>
             </a:r>
           </a:p>
         </p:txBody>
@@ -6467,7 +6556,7 @@
         </p:nvSpPr>
         <p:spPr>
           <a:xfrm>
-            <a:off x="731520" y="457200"/>
+            <a:off x="731520" y="411480"/>
             <a:ext cx="10698480" cy="365760"/>
           </a:xfrm>
           <a:prstGeom prst="rect">
@@ -6484,13 +6573,13 @@
             <a:pPr>
               <a:defRPr sz="1100" b="1">
                 <a:solidFill>
-                  <a:srgbClr val="0FAEC8"/>
+                  <a:srgbClr val="38D39F"/>
                 </a:solidFill>
                 <a:latin typeface="IBM Plex Mono"/>
               </a:defRPr>
             </a:pPr>
             <a:r>
-              <a:t>DEMO EN VIVO (90 SEGUNDOS) · NARRAR RESULTADOS, NO CLICS</a:t>
+              <a:t>EVIDENCIA TÉCNICA · AUDITABLE POR CUALQUIER PERSONA</a:t>
             </a:r>
           </a:p>
         </p:txBody>
@@ -6503,7 +6592,7 @@
         </p:nvSpPr>
         <p:spPr>
           <a:xfrm>
-            <a:off x="731520" y="822960"/>
+            <a:off x="731520" y="777240"/>
             <a:ext cx="10698480" cy="822960"/>
           </a:xfrm>
           <a:prstGeom prst="rect">
@@ -6518,7 +6607,7 @@
           <a:lstStyle/>
           <a:p>
             <a:pPr>
-              <a:defRPr sz="2800" b="1">
+              <a:defRPr sz="2700" b="1">
                 <a:solidFill>
                   <a:srgbClr val="F0F7FB"/>
                 </a:solidFill>
@@ -6526,7 +6615,7 @@
               </a:defRPr>
             </a:pPr>
             <a:r>
-              <a:t>UN SOLO FLUJO, </a:t>
+              <a:t>EVIDENCIA </a:t>
             </a:r>
             <a:r>
               <a:rPr b="1">
@@ -6534,7 +6623,15 @@
                   <a:srgbClr val="72E0ED"/>
                 </a:solidFill>
               </a:rPr>
-              <a:t>DE PUNTA A PUNTA</a:t>
+              <a:t>QUE SÍ VA</a:t>
+            </a:r>
+            <a:r>
+              <a:rPr b="1">
+                <a:solidFill>
+                  <a:srgbClr val="F0F7FB"/>
+                </a:solidFill>
+              </a:rPr>
+              <a:t> EN STELLAR</a:t>
             </a:r>
           </a:p>
         </p:txBody>
@@ -6547,14 +6644,14 @@
         </p:nvSpPr>
         <p:spPr>
           <a:xfrm>
-            <a:off x="731520" y="1828800"/>
-            <a:ext cx="2514600" cy="2926080"/>
+            <a:off x="731520" y="1783080"/>
+            <a:ext cx="5486400" cy="4160520"/>
           </a:xfrm>
           <a:prstGeom prst="rect">
             <a:avLst/>
           </a:prstGeom>
           <a:solidFill>
-            <a:srgbClr val="113459"/>
+            <a:srgbClr val="0D2744"/>
           </a:solidFill>
           <a:ln w="25400">
             <a:solidFill>
@@ -6592,8 +6689,8 @@
         </p:nvSpPr>
         <p:spPr>
           <a:xfrm>
-            <a:off x="914400" y="2011680"/>
-            <a:ext cx="2148840" cy="2560320"/>
+            <a:off x="1005840" y="2011680"/>
+            <a:ext cx="4937760" cy="3657600"/>
           </a:xfrm>
           <a:prstGeom prst="rect">
             <a:avLst/>
@@ -6607,7 +6704,7 @@
           <a:lstStyle/>
           <a:p>
             <a:pPr>
-              <a:defRPr sz="1000" b="1">
+              <a:defRPr sz="1100" b="1">
                 <a:solidFill>
                   <a:srgbClr val="0FAEC8"/>
                 </a:solidFill>
@@ -6615,7 +6712,23 @@
               </a:defRPr>
             </a:pPr>
             <a:r>
-              <a:t>PASO 1 (20 s)</a:t>
+              <a:t>SMART CONTRACT EN STELLAR TESTNET</a:t>
+            </a:r>
+          </a:p>
+          <a:p>
+            <a:pPr>
+              <a:spcBef>
+                <a:spcPts val="800"/>
+              </a:spcBef>
+              <a:defRPr sz="1100" b="1">
+                <a:solidFill>
+                  <a:srgbClr val="72E0ED"/>
+                </a:solidFill>
+                <a:latin typeface="IBM Plex Mono"/>
+              </a:defRPr>
+            </a:pPr>
+            <a:r>
+              <a:t>CAOAFGPATXWJ6KKGXFYHY42Q4N75NOWSR3NH3K2DT7QR3YSMDGT5P2HO</a:t>
             </a:r>
           </a:p>
           <a:p>
@@ -6623,112 +6736,24 @@
               <a:spcBef>
                 <a:spcPts val="600"/>
               </a:spcBef>
-              <a:defRPr sz="1500" b="1">
+            </a:pPr>
+            <a:r>
+              <a:rPr b="1" sz="1200">
                 <a:solidFill>
                   <a:srgbClr val="F0F7FB"/>
                 </a:solidFill>
-                <a:latin typeface="Space Grotesk"/>
-              </a:defRPr>
-            </a:pPr>
-            <a:r>
-              <a:t>1. HASH LOCAL</a:t>
-            </a:r>
-          </a:p>
-          <a:p>
-            <a:pPr>
-              <a:spcBef>
-                <a:spcPts val="800"/>
-              </a:spcBef>
-              <a:defRPr sz="1100">
+                <a:latin typeface="IBM Plex Mono"/>
+              </a:rPr>
+              <a:t>• Wasm Bytecode Hash:</a:t>
+            </a:r>
+            <a:r>
+              <a:rPr sz="1100">
                 <a:solidFill>
                   <a:srgbClr val="8FB6D3"/>
                 </a:solidFill>
                 <a:latin typeface="IBM Plex Mono"/>
-              </a:defRPr>
-            </a:pPr>
-            <a:r>
-              <a:t>Mateo sube su obra. La Web Crypto API calcula el hash SHA-256 en su RAM. El archivo original nunca viaja a la red.</a:t>
-            </a:r>
-          </a:p>
-        </p:txBody>
-      </p:sp>
-      <p:sp>
-        <p:nvSpPr>
-          <p:cNvPr id="7" name="Rectangle 6"/>
-          <p:cNvSpPr/>
-          <p:nvPr/>
-        </p:nvSpPr>
-        <p:spPr>
-          <a:xfrm>
-            <a:off x="3465576" y="1828800"/>
-            <a:ext cx="2514600" cy="2926080"/>
-          </a:xfrm>
-          <a:prstGeom prst="rect">
-            <a:avLst/>
-          </a:prstGeom>
-          <a:solidFill>
-            <a:srgbClr val="113459"/>
-          </a:solidFill>
-          <a:ln w="25400">
-            <a:solidFill>
-              <a:srgbClr val="72E0ED"/>
-            </a:solidFill>
-          </a:ln>
-        </p:spPr>
-        <p:style>
-          <a:lnRef idx="1">
-            <a:schemeClr val="accent1"/>
-          </a:lnRef>
-          <a:fillRef idx="3">
-            <a:schemeClr val="accent1"/>
-          </a:fillRef>
-          <a:effectRef idx="2">
-            <a:schemeClr val="accent1"/>
-          </a:effectRef>
-          <a:fontRef idx="minor">
-            <a:schemeClr val="lt1"/>
-          </a:fontRef>
-        </p:style>
-        <p:txBody>
-          <a:bodyPr rtlCol="0" anchor="ctr"/>
-          <a:lstStyle/>
-          <a:p>
-            <a:pPr algn="ctr"/>
-          </a:p>
-        </p:txBody>
-      </p:sp>
-      <p:sp>
-        <p:nvSpPr>
-          <p:cNvPr id="8" name="TextBox 7"/>
-          <p:cNvSpPr txBox="1"/>
-          <p:nvPr/>
-        </p:nvSpPr>
-        <p:spPr>
-          <a:xfrm>
-            <a:off x="3648456" y="2011680"/>
-            <a:ext cx="2148840" cy="2560320"/>
-          </a:xfrm>
-          <a:prstGeom prst="rect">
-            <a:avLst/>
-          </a:prstGeom>
-          <a:noFill/>
-        </p:spPr>
-        <p:txBody>
-          <a:bodyPr wrap="square">
-            <a:spAutoFit/>
-          </a:bodyPr>
-          <a:lstStyle/>
-          <a:p>
-            <a:pPr>
-              <a:defRPr sz="1000" b="1">
-                <a:solidFill>
-                  <a:srgbClr val="72E0ED"/>
-                </a:solidFill>
-                <a:latin typeface="IBM Plex Mono"/>
-              </a:defRPr>
-            </a:pPr>
-            <a:r>
-              <a:t>PASO 2 (25 s)</a:t>
+              </a:rPr>
+              <a:t> ba7d1753ecf002984aee4a87c80b64af...</a:t>
             </a:r>
           </a:p>
           <a:p>
@@ -6736,112 +6761,24 @@
               <a:spcBef>
                 <a:spcPts val="600"/>
               </a:spcBef>
-              <a:defRPr sz="1500" b="1">
+            </a:pPr>
+            <a:r>
+              <a:rPr b="1" sz="1200">
                 <a:solidFill>
                   <a:srgbClr val="F0F7FB"/>
                 </a:solidFill>
-                <a:latin typeface="Space Grotesk"/>
-              </a:defRPr>
-            </a:pPr>
-            <a:r>
-              <a:t>2. SOROBAN</a:t>
-            </a:r>
-          </a:p>
-          <a:p>
-            <a:pPr>
-              <a:spcBef>
-                <a:spcPts val="800"/>
-              </a:spcBef>
-              <a:defRPr sz="1100">
+                <a:latin typeface="IBM Plex Mono"/>
+              </a:rPr>
+              <a:t>• Tx Registro en vivo:</a:t>
+            </a:r>
+            <a:r>
+              <a:rPr sz="1100">
                 <a:solidFill>
                   <a:srgbClr val="8FB6D3"/>
                 </a:solidFill>
                 <a:latin typeface="IBM Plex Mono"/>
-              </a:defRPr>
-            </a:pPr>
-            <a:r>
-              <a:t>El smart contract en Stellar Testnet estampa la huella inmutable y emite el evento nativo work_reg.</a:t>
-            </a:r>
-          </a:p>
-        </p:txBody>
-      </p:sp>
-      <p:sp>
-        <p:nvSpPr>
-          <p:cNvPr id="9" name="Rectangle 8"/>
-          <p:cNvSpPr/>
-          <p:nvPr/>
-        </p:nvSpPr>
-        <p:spPr>
-          <a:xfrm>
-            <a:off x="6199632" y="1828800"/>
-            <a:ext cx="2514600" cy="2926080"/>
-          </a:xfrm>
-          <a:prstGeom prst="rect">
-            <a:avLst/>
-          </a:prstGeom>
-          <a:solidFill>
-            <a:srgbClr val="113459"/>
-          </a:solidFill>
-          <a:ln w="25400">
-            <a:solidFill>
-              <a:srgbClr val="38D39F"/>
-            </a:solidFill>
-          </a:ln>
-        </p:spPr>
-        <p:style>
-          <a:lnRef idx="1">
-            <a:schemeClr val="accent1"/>
-          </a:lnRef>
-          <a:fillRef idx="3">
-            <a:schemeClr val="accent1"/>
-          </a:fillRef>
-          <a:effectRef idx="2">
-            <a:schemeClr val="accent1"/>
-          </a:effectRef>
-          <a:fontRef idx="minor">
-            <a:schemeClr val="lt1"/>
-          </a:fontRef>
-        </p:style>
-        <p:txBody>
-          <a:bodyPr rtlCol="0" anchor="ctr"/>
-          <a:lstStyle/>
-          <a:p>
-            <a:pPr algn="ctr"/>
-          </a:p>
-        </p:txBody>
-      </p:sp>
-      <p:sp>
-        <p:nvSpPr>
-          <p:cNvPr id="10" name="TextBox 9"/>
-          <p:cNvSpPr txBox="1"/>
-          <p:nvPr/>
-        </p:nvSpPr>
-        <p:spPr>
-          <a:xfrm>
-            <a:off x="6382512" y="2011680"/>
-            <a:ext cx="2148840" cy="2560320"/>
-          </a:xfrm>
-          <a:prstGeom prst="rect">
-            <a:avLst/>
-          </a:prstGeom>
-          <a:noFill/>
-        </p:spPr>
-        <p:txBody>
-          <a:bodyPr wrap="square">
-            <a:spAutoFit/>
-          </a:bodyPr>
-          <a:lstStyle/>
-          <a:p>
-            <a:pPr>
-              <a:defRPr sz="1000" b="1">
-                <a:solidFill>
-                  <a:srgbClr val="38D39F"/>
-                </a:solidFill>
-                <a:latin typeface="IBM Plex Mono"/>
-              </a:defRPr>
-            </a:pPr>
-            <a:r>
-              <a:t>PASO 3 (25 s)</a:t>
+              </a:rPr>
+              <a:t> 725e126cc7998b795f32... (Evento nativo work_reg)</a:t>
             </a:r>
           </a:p>
           <a:p>
@@ -6849,112 +6786,24 @@
               <a:spcBef>
                 <a:spcPts val="600"/>
               </a:spcBef>
-              <a:defRPr sz="1500" b="1">
+            </a:pPr>
+            <a:r>
+              <a:rPr b="1" sz="1200">
                 <a:solidFill>
                   <a:srgbClr val="F0F7FB"/>
                 </a:solidFill>
-                <a:latin typeface="Space Grotesk"/>
-              </a:defRPr>
-            </a:pPr>
-            <a:r>
-              <a:t>3. AUDITORÍA</a:t>
-            </a:r>
-          </a:p>
-          <a:p>
-            <a:pPr>
-              <a:spcBef>
-                <a:spcPts val="800"/>
-              </a:spcBef>
-              <a:defRPr sz="1100">
+                <a:latin typeface="IBM Plex Mono"/>
+              </a:rPr>
+              <a:t>• Tx Licencia de derechos:</a:t>
+            </a:r>
+            <a:r>
+              <a:rPr sz="1100">
                 <a:solidFill>
                   <a:srgbClr val="8FB6D3"/>
                 </a:solidFill>
                 <a:latin typeface="IBM Plex Mono"/>
-              </a:defRPr>
-            </a:pPr>
-            <a:r>
-              <a:t>La editorial entra a /verificar, sube el archivo recibido y comprueba autoría y fecha sin tener cuenta.</a:t>
-            </a:r>
-          </a:p>
-        </p:txBody>
-      </p:sp>
-      <p:sp>
-        <p:nvSpPr>
-          <p:cNvPr id="11" name="Rectangle 10"/>
-          <p:cNvSpPr/>
-          <p:nvPr/>
-        </p:nvSpPr>
-        <p:spPr>
-          <a:xfrm>
-            <a:off x="8933688" y="1828800"/>
-            <a:ext cx="2514600" cy="2926080"/>
-          </a:xfrm>
-          <a:prstGeom prst="rect">
-            <a:avLst/>
-          </a:prstGeom>
-          <a:solidFill>
-            <a:srgbClr val="113459"/>
-          </a:solidFill>
-          <a:ln w="25400">
-            <a:solidFill>
-              <a:srgbClr val="F97316"/>
-            </a:solidFill>
-          </a:ln>
-        </p:spPr>
-        <p:style>
-          <a:lnRef idx="1">
-            <a:schemeClr val="accent1"/>
-          </a:lnRef>
-          <a:fillRef idx="3">
-            <a:schemeClr val="accent1"/>
-          </a:fillRef>
-          <a:effectRef idx="2">
-            <a:schemeClr val="accent1"/>
-          </a:effectRef>
-          <a:fontRef idx="minor">
-            <a:schemeClr val="lt1"/>
-          </a:fontRef>
-        </p:style>
-        <p:txBody>
-          <a:bodyPr rtlCol="0" anchor="ctr"/>
-          <a:lstStyle/>
-          <a:p>
-            <a:pPr algn="ctr"/>
-          </a:p>
-        </p:txBody>
-      </p:sp>
-      <p:sp>
-        <p:nvSpPr>
-          <p:cNvPr id="12" name="TextBox 11"/>
-          <p:cNvSpPr txBox="1"/>
-          <p:nvPr/>
-        </p:nvSpPr>
-        <p:spPr>
-          <a:xfrm>
-            <a:off x="9116568" y="2011680"/>
-            <a:ext cx="2148840" cy="2560320"/>
-          </a:xfrm>
-          <a:prstGeom prst="rect">
-            <a:avLst/>
-          </a:prstGeom>
-          <a:noFill/>
-        </p:spPr>
-        <p:txBody>
-          <a:bodyPr wrap="square">
-            <a:spAutoFit/>
-          </a:bodyPr>
-          <a:lstStyle/>
-          <a:p>
-            <a:pPr>
-              <a:defRPr sz="1000" b="1">
-                <a:solidFill>
-                  <a:srgbClr val="F97316"/>
-                </a:solidFill>
-                <a:latin typeface="IBM Plex Mono"/>
-              </a:defRPr>
-            </a:pPr>
-            <a:r>
-              <a:t>PASO 4 (20 s)</a:t>
+              </a:rPr>
+              <a:t> 30f6f7e9a1df1187d0a6... (Evento nativo right_evt)</a:t>
             </a:r>
           </a:p>
           <a:p>
@@ -6962,51 +6811,44 @@
               <a:spcBef>
                 <a:spcPts val="600"/>
               </a:spcBef>
-              <a:defRPr sz="1500" b="1">
+            </a:pPr>
+            <a:r>
+              <a:rPr b="1" sz="1200">
                 <a:solidFill>
                   <a:srgbClr val="F0F7FB"/>
                 </a:solidFill>
-                <a:latin typeface="Space Grotesk"/>
-              </a:defRPr>
-            </a:pPr>
-            <a:r>
-              <a:t>4. COMPROBANTE</a:t>
-            </a:r>
-          </a:p>
-          <a:p>
-            <a:pPr>
-              <a:spcBef>
-                <a:spcPts val="800"/>
-              </a:spcBef>
-              <a:defRPr sz="1100">
+                <a:latin typeface="IBM Plex Mono"/>
+              </a:rPr>
+              <a:t>• Explorador Stellar Expert:</a:t>
+            </a:r>
+            <a:r>
+              <a:rPr sz="1100">
                 <a:solidFill>
                   <a:srgbClr val="8FB6D3"/>
                 </a:solidFill>
                 <a:latin typeface="IBM Plex Mono"/>
-              </a:defRPr>
-            </a:pPr>
-            <a:r>
-              <a:t>Inspección pública del ledger en Stellar Expert y descarga de certificado imprimible con QR.</a:t>
-            </a:r>
-          </a:p>
-        </p:txBody>
-      </p:sp>
-      <p:sp>
-        <p:nvSpPr>
-          <p:cNvPr id="13" name="Rectangle 12"/>
+              </a:rPr>
+              <a:t> Consultable públicamente sin permisos</a:t>
+            </a:r>
+          </a:p>
+        </p:txBody>
+      </p:sp>
+      <p:sp>
+        <p:nvSpPr>
+          <p:cNvPr id="7" name="Rectangle 6"/>
           <p:cNvSpPr/>
           <p:nvPr/>
         </p:nvSpPr>
         <p:spPr>
           <a:xfrm>
-            <a:off x="731520" y="4937760"/>
-            <a:ext cx="10728655" cy="1005840"/>
+            <a:off x="6492240" y="1783080"/>
+            <a:ext cx="4937760" cy="4160520"/>
           </a:xfrm>
           <a:prstGeom prst="rect">
             <a:avLst/>
           </a:prstGeom>
           <a:solidFill>
-            <a:srgbClr val="0D2744"/>
+            <a:srgbClr val="113459"/>
           </a:solidFill>
           <a:ln w="25400">
             <a:solidFill>
@@ -7038,14 +6880,14 @@
       </p:sp>
       <p:sp>
         <p:nvSpPr>
-          <p:cNvPr id="14" name="TextBox 13"/>
+          <p:cNvPr id="8" name="TextBox 7"/>
           <p:cNvSpPr txBox="1"/>
           <p:nvPr/>
         </p:nvSpPr>
         <p:spPr>
           <a:xfrm>
-            <a:off x="1005840" y="5029200"/>
-            <a:ext cx="10180015" cy="822960"/>
+            <a:off x="6766560" y="2011680"/>
+            <a:ext cx="4389120" cy="3657600"/>
           </a:xfrm>
           <a:prstGeom prst="rect">
             <a:avLst/>
@@ -7067,36 +6909,67 @@
               </a:defRPr>
             </a:pPr>
             <a:r>
-              <a:t>PLAN B EN CASO DE CONTINGENCIA DE RED:</a:t>
+              <a:t>REPOSITORIO &amp; REPRODUCIBILIDAD</a:t>
             </a:r>
           </a:p>
           <a:p>
             <a:pPr>
               <a:spcBef>
-                <a:spcPts val="400"/>
+                <a:spcPts val="600"/>
+              </a:spcBef>
+              <a:defRPr sz="2000" b="1">
+                <a:solidFill>
+                  <a:srgbClr val="F0F7FB"/>
+                </a:solidFill>
+                <a:latin typeface="Space Grotesk"/>
+              </a:defRPr>
+            </a:pPr>
+            <a:r>
+              <a:t>GitHub: nidaela/Authory</a:t>
+            </a:r>
+          </a:p>
+          <a:p>
+            <a:pPr>
+              <a:spcBef>
+                <a:spcPts val="1000"/>
               </a:spcBef>
               <a:defRPr sz="1200">
                 <a:solidFill>
-                  <a:srgbClr val="F0F7FB"/>
+                  <a:srgbClr val="8FB6D3"/>
                 </a:solidFill>
                 <a:latin typeface="IBM Plex Mono"/>
               </a:defRPr>
             </a:pPr>
             <a:r>
-              <a:t>Si la red de pruebas demora más de 15 segundos, switch inmediato al video de respaldo grabado. | App en vivo: authority-khaki.vercel.app</a:t>
-            </a:r>
-          </a:p>
-        </p:txBody>
-      </p:sp>
-      <p:sp>
-        <p:nvSpPr>
-          <p:cNvPr id="15" name="Rectangle 14"/>
+              <a:t>• Stack: Next.js 16 (App Router) + React 19 + Tailwind CSS 4.</a:t>
+            </a:r>
+            <a:br/>
+            <a:br/>
+            <a:r>
+              <a:t>• Pruebas: 9/9 suites de pruebas unitarias y focales passing.</a:t>
+            </a:r>
+            <a:br/>
+            <a:br/>
+            <a:r>
+              <a:t>• Base de Datos: Persistencia híbrida en Supabase y archivos off-chain.</a:t>
+            </a:r>
+            <a:br/>
+            <a:br/>
+            <a:r>
+              <a:t>• Despliegue en Producción: authority-khaki.vercel.app</a:t>
+            </a:r>
+          </a:p>
+        </p:txBody>
+      </p:sp>
+      <p:sp>
+        <p:nvSpPr>
+          <p:cNvPr id="9" name="Rectangle 8"/>
           <p:cNvSpPr/>
           <p:nvPr/>
         </p:nvSpPr>
         <p:spPr>
           <a:xfrm>
-            <a:off x="731520" y="6217920"/>
+            <a:off x="731520" y="6236208"/>
             <a:ext cx="10728655" cy="18288"/>
           </a:xfrm>
           <a:prstGeom prst="rect">
@@ -7135,13 +7008,13 @@
       </p:sp>
       <p:sp>
         <p:nvSpPr>
-          <p:cNvPr id="16" name="TextBox 15"/>
+          <p:cNvPr id="10" name="TextBox 9"/>
           <p:cNvSpPr txBox="1"/>
           <p:nvPr/>
         </p:nvSpPr>
         <p:spPr>
           <a:xfrm>
-            <a:off x="731520" y="6291072"/>
+            <a:off x="731520" y="6309360"/>
             <a:ext cx="7772400" cy="320040"/>
           </a:xfrm>
           <a:prstGeom prst="rect">
@@ -7164,20 +7037,20 @@
               </a:defRPr>
             </a:pPr>
             <a:r>
-              <a:t>Regla de la demo: Narrar consecuencias para Mateo, nunca 'le doy clic al botón azul'.</a:t>
-            </a:r>
-          </a:p>
-        </p:txBody>
-      </p:sp>
-      <p:sp>
-        <p:nvSpPr>
-          <p:cNvPr id="17" name="TextBox 16"/>
+              <a:t>Lo que sobra: Capturas sin enlace o commits vacíos. Lo que vale: El hash consultable.</a:t>
+            </a:r>
+          </a:p>
+        </p:txBody>
+      </p:sp>
+      <p:sp>
+        <p:nvSpPr>
+          <p:cNvPr id="11" name="TextBox 10"/>
           <p:cNvSpPr txBox="1"/>
           <p:nvPr/>
         </p:nvSpPr>
         <p:spPr>
           <a:xfrm>
-            <a:off x="8686800" y="6291072"/>
+            <a:off x="8686800" y="6309360"/>
             <a:ext cx="2773375" cy="320040"/>
           </a:xfrm>
           <a:prstGeom prst="rect">
@@ -7200,7 +7073,7 @@
               </a:defRPr>
             </a:pPr>
             <a:r>
-              <a:t>1:40 - 3:10 (90 s)</a:t>
+              <a:t>1:55 - 2:25 (30 s)</a:t>
             </a:r>
           </a:p>
         </p:txBody>
@@ -7276,7 +7149,7 @@
         </p:nvSpPr>
         <p:spPr>
           <a:xfrm>
-            <a:off x="731520" y="457200"/>
+            <a:off x="731520" y="411480"/>
             <a:ext cx="10698480" cy="365760"/>
           </a:xfrm>
           <a:prstGeom prst="rect">
@@ -7293,13 +7166,13 @@
             <a:pPr>
               <a:defRPr sz="1100" b="1">
                 <a:solidFill>
-                  <a:srgbClr val="38D39F"/>
+                  <a:srgbClr val="72E0ED"/>
                 </a:solidFill>
                 <a:latin typeface="IBM Plex Mono"/>
               </a:defRPr>
             </a:pPr>
             <a:r>
-              <a:t>EVIDENCIA TÉCNICA · AUDITABLE POR CUALQUIER PERSONA</a:t>
+              <a:t>VALIDACIÓN HONESTA · LO QUE ES CIERTO Y LO QUE FALTA</a:t>
             </a:r>
           </a:p>
         </p:txBody>
@@ -7312,7 +7185,7 @@
         </p:nvSpPr>
         <p:spPr>
           <a:xfrm>
-            <a:off x="731520" y="822960"/>
+            <a:off x="731520" y="777240"/>
             <a:ext cx="10698480" cy="822960"/>
           </a:xfrm>
           <a:prstGeom prst="rect">
@@ -7327,7 +7200,7 @@
           <a:lstStyle/>
           <a:p>
             <a:pPr>
-              <a:defRPr sz="2800" b="1">
+              <a:defRPr sz="2700" b="1">
                 <a:solidFill>
                   <a:srgbClr val="F0F7FB"/>
                 </a:solidFill>
@@ -7335,15 +7208,12 @@
               </a:defRPr>
             </a:pPr>
             <a:r>
-              <a:t>EVIDENCIA </a:t>
-            </a:r>
-            <a:r>
               <a:rPr b="1">
                 <a:solidFill>
                   <a:srgbClr val="72E0ED"/>
                 </a:solidFill>
               </a:rPr>
-              <a:t>QUE SÍ VA</a:t>
+              <a:t>LO COMPROBADO</a:t>
             </a:r>
             <a:r>
               <a:rPr b="1">
@@ -7351,7 +7221,7 @@
                   <a:srgbClr val="F0F7FB"/>
                 </a:solidFill>
               </a:rPr>
-              <a:t> EN STELLAR</a:t>
+              <a:t> Y LO POR COMPROBAR</a:t>
             </a:r>
           </a:p>
         </p:txBody>
@@ -7364,14 +7234,127 @@
         </p:nvSpPr>
         <p:spPr>
           <a:xfrm>
-            <a:off x="731520" y="1828800"/>
-            <a:ext cx="5486400" cy="4114800"/>
+            <a:off x="731520" y="1783080"/>
+            <a:ext cx="3383280" cy="4160520"/>
           </a:xfrm>
           <a:prstGeom prst="rect">
             <a:avLst/>
           </a:prstGeom>
           <a:solidFill>
-            <a:srgbClr val="0D2744"/>
+            <a:srgbClr val="113459"/>
+          </a:solidFill>
+          <a:ln w="25400">
+            <a:solidFill>
+              <a:srgbClr val="F97316"/>
+            </a:solidFill>
+          </a:ln>
+        </p:spPr>
+        <p:style>
+          <a:lnRef idx="1">
+            <a:schemeClr val="accent1"/>
+          </a:lnRef>
+          <a:fillRef idx="3">
+            <a:schemeClr val="accent1"/>
+          </a:fillRef>
+          <a:effectRef idx="2">
+            <a:schemeClr val="accent1"/>
+          </a:effectRef>
+          <a:fontRef idx="minor">
+            <a:schemeClr val="lt1"/>
+          </a:fontRef>
+        </p:style>
+        <p:txBody>
+          <a:bodyPr rtlCol="0" anchor="ctr"/>
+          <a:lstStyle/>
+          <a:p>
+            <a:pPr algn="ctr"/>
+          </a:p>
+        </p:txBody>
+      </p:sp>
+      <p:sp>
+        <p:nvSpPr>
+          <p:cNvPr id="6" name="TextBox 5"/>
+          <p:cNvSpPr txBox="1"/>
+          <p:nvPr/>
+        </p:nvSpPr>
+        <p:spPr>
+          <a:xfrm>
+            <a:off x="914400" y="2011680"/>
+            <a:ext cx="3017520" cy="3657600"/>
+          </a:xfrm>
+          <a:prstGeom prst="rect">
+            <a:avLst/>
+          </a:prstGeom>
+          <a:noFill/>
+        </p:spPr>
+        <p:txBody>
+          <a:bodyPr wrap="square">
+            <a:spAutoFit/>
+          </a:bodyPr>
+          <a:lstStyle/>
+          <a:p>
+            <a:pPr>
+              <a:defRPr sz="1100" b="1">
+                <a:solidFill>
+                  <a:srgbClr val="F97316"/>
+                </a:solidFill>
+                <a:latin typeface="IBM Plex Mono"/>
+              </a:defRPr>
+            </a:pPr>
+            <a:r>
+              <a:t>«CREEMOS»</a:t>
+            </a:r>
+          </a:p>
+          <a:p>
+            <a:pPr>
+              <a:spcBef>
+                <a:spcPts val="800"/>
+              </a:spcBef>
+              <a:defRPr sz="1700" b="1">
+                <a:solidFill>
+                  <a:srgbClr val="F0F7FB"/>
+                </a:solidFill>
+                <a:latin typeface="Space Grotesk"/>
+              </a:defRPr>
+            </a:pPr>
+            <a:r>
+              <a:t>HIPÓTESIS CRÍTICA</a:t>
+            </a:r>
+          </a:p>
+          <a:p>
+            <a:pPr>
+              <a:spcBef>
+                <a:spcPts val="1200"/>
+              </a:spcBef>
+              <a:defRPr sz="1250">
+                <a:solidFill>
+                  <a:srgbClr val="8FB6D3"/>
+                </a:solidFill>
+                <a:latin typeface="IBM Plex Mono"/>
+              </a:defRPr>
+            </a:pPr>
+            <a:r>
+              <a:t>4 de cada 5 ilustradores independientes incluirán un enlace verificable de Authory en sus presupuestos comerciales para protegerse del plagio.</a:t>
+            </a:r>
+          </a:p>
+        </p:txBody>
+      </p:sp>
+      <p:sp>
+        <p:nvSpPr>
+          <p:cNvPr id="7" name="Rectangle 6"/>
+          <p:cNvSpPr/>
+          <p:nvPr/>
+        </p:nvSpPr>
+        <p:spPr>
+          <a:xfrm>
+            <a:off x="4403750" y="1783080"/>
+            <a:ext cx="3383280" cy="4160520"/>
+          </a:xfrm>
+          <a:prstGeom prst="rect">
+            <a:avLst/>
+          </a:prstGeom>
+          <a:solidFill>
+            <a:srgbClr val="113459"/>
           </a:solidFill>
           <a:ln w="25400">
             <a:solidFill>
@@ -7403,14 +7386,14 @@
       </p:sp>
       <p:sp>
         <p:nvSpPr>
-          <p:cNvPr id="6" name="TextBox 5"/>
+          <p:cNvPr id="8" name="TextBox 7"/>
           <p:cNvSpPr txBox="1"/>
           <p:nvPr/>
         </p:nvSpPr>
         <p:spPr>
           <a:xfrm>
-            <a:off x="1005840" y="2103120"/>
-            <a:ext cx="4937760" cy="3566160"/>
+            <a:off x="4586630" y="2011680"/>
+            <a:ext cx="3017520" cy="3657600"/>
           </a:xfrm>
           <a:prstGeom prst="rect">
             <a:avLst/>
@@ -7432,7 +7415,7 @@
               </a:defRPr>
             </a:pPr>
             <a:r>
-              <a:t>SMART CONTRACT EN STELLAR TESTNET</a:t>
+              <a:t>«OBSERVAMOS»</a:t>
             </a:r>
           </a:p>
           <a:p>
@@ -7440,129 +7423,45 @@
               <a:spcBef>
                 <a:spcPts val="800"/>
               </a:spcBef>
-              <a:defRPr sz="1100" b="1">
-                <a:solidFill>
-                  <a:srgbClr val="72E0ED"/>
-                </a:solidFill>
-                <a:latin typeface="IBM Plex Mono"/>
-              </a:defRPr>
-            </a:pPr>
-            <a:r>
-              <a:t>CAOAFGPATXWJ6KKGXFYHY42Q4N75NOWSR3NH3K2DT7QR3YSMDGT5P2HO</a:t>
+              <a:defRPr sz="1700" b="1">
+                <a:solidFill>
+                  <a:srgbClr val="F0F7FB"/>
+                </a:solidFill>
+                <a:latin typeface="Space Grotesk"/>
+              </a:defRPr>
+            </a:pPr>
+            <a:r>
+              <a:t>AJUSTE INTERNO</a:t>
             </a:r>
           </a:p>
           <a:p>
             <a:pPr>
               <a:spcBef>
-                <a:spcPts val="600"/>
+                <a:spcPts val="1200"/>
               </a:spcBef>
-            </a:pPr>
-            <a:r>
-              <a:rPr b="1" sz="1200">
-                <a:solidFill>
-                  <a:srgbClr val="F0F7FB"/>
+              <a:defRPr sz="1250">
+                <a:solidFill>
+                  <a:srgbClr val="8FB6D3"/>
                 </a:solidFill>
                 <a:latin typeface="IBM Plex Mono"/>
-              </a:rPr>
-              <a:t>• Wasm Bytecode Hash:</a:t>
-            </a:r>
-            <a:r>
-              <a:rPr sz="1100">
-                <a:solidFill>
-                  <a:srgbClr val="8FB6D3"/>
-                </a:solidFill>
-                <a:latin typeface="IBM Plex Mono"/>
-              </a:rPr>
-              <a:t> ba7d1753ecf002984aee4a87c80b64af...</a:t>
-            </a:r>
-          </a:p>
-          <a:p>
-            <a:pPr>
-              <a:spcBef>
-                <a:spcPts val="600"/>
-              </a:spcBef>
-            </a:pPr>
-            <a:r>
-              <a:rPr b="1" sz="1200">
-                <a:solidFill>
-                  <a:srgbClr val="F0F7FB"/>
-                </a:solidFill>
-                <a:latin typeface="IBM Plex Mono"/>
-              </a:rPr>
-              <a:t>• Tx Registro en vivo:</a:t>
-            </a:r>
-            <a:r>
-              <a:rPr sz="1100">
-                <a:solidFill>
-                  <a:srgbClr val="8FB6D3"/>
-                </a:solidFill>
-                <a:latin typeface="IBM Plex Mono"/>
-              </a:rPr>
-              <a:t> 725e126cc7998b795f32... (Evento work_reg)</a:t>
-            </a:r>
-          </a:p>
-          <a:p>
-            <a:pPr>
-              <a:spcBef>
-                <a:spcPts val="600"/>
-              </a:spcBef>
-            </a:pPr>
-            <a:r>
-              <a:rPr b="1" sz="1200">
-                <a:solidFill>
-                  <a:srgbClr val="F0F7FB"/>
-                </a:solidFill>
-                <a:latin typeface="IBM Plex Mono"/>
-              </a:rPr>
-              <a:t>• Tx Licencia de derechos:</a:t>
-            </a:r>
-            <a:r>
-              <a:rPr sz="1100">
-                <a:solidFill>
-                  <a:srgbClr val="8FB6D3"/>
-                </a:solidFill>
-                <a:latin typeface="IBM Plex Mono"/>
-              </a:rPr>
-              <a:t> 30f6f7e9a1df1187d0a6... (Evento right_evt)</a:t>
-            </a:r>
-          </a:p>
-          <a:p>
-            <a:pPr>
-              <a:spcBef>
-                <a:spcPts val="600"/>
-              </a:spcBef>
-            </a:pPr>
-            <a:r>
-              <a:rPr b="1" sz="1200">
-                <a:solidFill>
-                  <a:srgbClr val="F0F7FB"/>
-                </a:solidFill>
-                <a:latin typeface="IBM Plex Mono"/>
-              </a:rPr>
-              <a:t>• Explorador Stellar Expert:</a:t>
-            </a:r>
-            <a:r>
-              <a:rPr sz="1100">
-                <a:solidFill>
-                  <a:srgbClr val="8FB6D3"/>
-                </a:solidFill>
-                <a:latin typeface="IBM Plex Mono"/>
-              </a:rPr>
-              <a:t> Consultable públicamente sin permisos</a:t>
-            </a:r>
-          </a:p>
-        </p:txBody>
-      </p:sp>
-      <p:sp>
-        <p:nvSpPr>
-          <p:cNvPr id="7" name="Rectangle 6"/>
+              </a:defRPr>
+            </a:pPr>
+            <a:r>
+              <a:t>Exigir wallet y gas en el onboarding expulsaba a creadores Web2. Ajustamos la UX para calcular SHA-256 en RAM instantáneamente sin barreras de entrada.</a:t>
+            </a:r>
+          </a:p>
+        </p:txBody>
+      </p:sp>
+      <p:sp>
+        <p:nvSpPr>
+          <p:cNvPr id="9" name="Rectangle 8"/>
           <p:cNvSpPr/>
           <p:nvPr/>
         </p:nvSpPr>
         <p:spPr>
           <a:xfrm>
-            <a:off x="6492240" y="1828800"/>
-            <a:ext cx="4937760" cy="4114800"/>
+            <a:off x="8075980" y="1783080"/>
+            <a:ext cx="3383280" cy="4160520"/>
           </a:xfrm>
           <a:prstGeom prst="rect">
             <a:avLst/>
@@ -7572,7 +7471,7 @@
           </a:solidFill>
           <a:ln w="25400">
             <a:solidFill>
-              <a:srgbClr val="1A4975"/>
+              <a:srgbClr val="38D39F"/>
             </a:solidFill>
           </a:ln>
         </p:spPr>
@@ -7600,14 +7499,14 @@
       </p:sp>
       <p:sp>
         <p:nvSpPr>
-          <p:cNvPr id="8" name="TextBox 7"/>
+          <p:cNvPr id="10" name="TextBox 9"/>
           <p:cNvSpPr txBox="1"/>
           <p:nvPr/>
         </p:nvSpPr>
         <p:spPr>
           <a:xfrm>
-            <a:off x="6766560" y="2103120"/>
-            <a:ext cx="4389120" cy="3566160"/>
+            <a:off x="8258860" y="2011680"/>
+            <a:ext cx="3017520" cy="3657600"/>
           </a:xfrm>
           <a:prstGeom prst="rect">
             <a:avLst/>
@@ -7623,21 +7522,21 @@
             <a:pPr>
               <a:defRPr sz="1100" b="1">
                 <a:solidFill>
-                  <a:srgbClr val="72E0ED"/>
+                  <a:srgbClr val="38D39F"/>
                 </a:solidFill>
                 <a:latin typeface="IBM Plex Mono"/>
               </a:defRPr>
             </a:pPr>
             <a:r>
-              <a:t>REPOSITORIO &amp; REPRODUCIBILIDAD</a:t>
+              <a:t>«COMPROBAMOS»</a:t>
             </a:r>
           </a:p>
           <a:p>
             <a:pPr>
               <a:spcBef>
-                <a:spcPts val="600"/>
+                <a:spcPts val="800"/>
               </a:spcBef>
-              <a:defRPr sz="2000" b="1">
+              <a:defRPr sz="1700" b="1">
                 <a:solidFill>
                   <a:srgbClr val="F0F7FB"/>
                 </a:solidFill>
@@ -7645,15 +7544,15 @@
               </a:defRPr>
             </a:pPr>
             <a:r>
-              <a:t>GitHub: nidaela/Authory</a:t>
+              <a:t>EVIDENCIA TÉCNICA</a:t>
             </a:r>
           </a:p>
           <a:p>
             <a:pPr>
               <a:spcBef>
-                <a:spcPts val="1000"/>
+                <a:spcPts val="1200"/>
               </a:spcBef>
-              <a:defRPr sz="1200">
+              <a:defRPr sz="1250">
                 <a:solidFill>
                   <a:srgbClr val="8FB6D3"/>
                 </a:solidFill>
@@ -7661,35 +7560,20 @@
               </a:defRPr>
             </a:pPr>
             <a:r>
-              <a:t>• Stack: Next.js 16 (App Router) + React 19 + Tailwind CSS 4.</a:t>
-            </a:r>
-            <a:br/>
-            <a:br/>
-            <a:r>
-              <a:t>• Pruebas: 9/9 suites de pruebas unitarias y focales passing.</a:t>
-            </a:r>
-            <a:br/>
-            <a:br/>
-            <a:r>
-              <a:t>• Base de Datos: Persistencia híbrida en Supabase y archivos off-chain.</a:t>
-            </a:r>
-            <a:br/>
-            <a:br/>
-            <a:r>
-              <a:t>• Despliegue en Producción: authority-khaki.vercel.app</a:t>
-            </a:r>
-          </a:p>
-        </p:txBody>
-      </p:sp>
-      <p:sp>
-        <p:nvSpPr>
-          <p:cNvPr id="9" name="Rectangle 8"/>
+              <a:t>Smart contract propio de 5 métodos en Soroban ejecutando atestaciones inmutables en menos de 3 segundos sobre Testnet con eventos nativos.</a:t>
+            </a:r>
+          </a:p>
+        </p:txBody>
+      </p:sp>
+      <p:sp>
+        <p:nvSpPr>
+          <p:cNvPr id="11" name="Rectangle 10"/>
           <p:cNvSpPr/>
           <p:nvPr/>
         </p:nvSpPr>
         <p:spPr>
           <a:xfrm>
-            <a:off x="731520" y="6217920"/>
+            <a:off x="731520" y="6236208"/>
             <a:ext cx="10728655" cy="18288"/>
           </a:xfrm>
           <a:prstGeom prst="rect">
@@ -7728,13 +7612,13 @@
       </p:sp>
       <p:sp>
         <p:nvSpPr>
-          <p:cNvPr id="10" name="TextBox 9"/>
+          <p:cNvPr id="12" name="TextBox 11"/>
           <p:cNvSpPr txBox="1"/>
           <p:nvPr/>
         </p:nvSpPr>
         <p:spPr>
           <a:xfrm>
-            <a:off x="731520" y="6291072"/>
+            <a:off x="731520" y="6309360"/>
             <a:ext cx="7772400" cy="320040"/>
           </a:xfrm>
           <a:prstGeom prst="rect">
@@ -7757,20 +7641,20 @@
               </a:defRPr>
             </a:pPr>
             <a:r>
-              <a:t>Lo que sobra: Capturas sin enlace o commits vacíos. Lo que vale: El hash consultable.</a:t>
-            </a:r>
-          </a:p>
-        </p:txBody>
-      </p:sp>
-      <p:sp>
-        <p:nvSpPr>
-          <p:cNvPr id="11" name="TextBox 10"/>
+              <a:t>Decir con honestidad lo que falta no debilita la presentación: la hace creíble.</a:t>
+            </a:r>
+          </a:p>
+        </p:txBody>
+      </p:sp>
+      <p:sp>
+        <p:nvSpPr>
+          <p:cNvPr id="13" name="TextBox 12"/>
           <p:cNvSpPr txBox="1"/>
           <p:nvPr/>
         </p:nvSpPr>
         <p:spPr>
           <a:xfrm>
-            <a:off x="8686800" y="6291072"/>
+            <a:off x="8686800" y="6309360"/>
             <a:ext cx="2773375" cy="320040"/>
           </a:xfrm>
           <a:prstGeom prst="rect">
@@ -7793,7 +7677,7 @@
               </a:defRPr>
             </a:pPr>
             <a:r>
-              <a:t>3:10 - 3:35 (25 s)</a:t>
+              <a:t>2:25 - 2:45 (20 s)</a:t>
             </a:r>
           </a:p>
         </p:txBody>
@@ -7869,7 +7753,7 @@
         </p:nvSpPr>
         <p:spPr>
           <a:xfrm>
-            <a:off x="731520" y="457200"/>
+            <a:off x="731520" y="411480"/>
             <a:ext cx="10698480" cy="365760"/>
           </a:xfrm>
           <a:prstGeom prst="rect">
@@ -7886,13 +7770,13 @@
             <a:pPr>
               <a:defRPr sz="1100" b="1">
                 <a:solidFill>
-                  <a:srgbClr val="72E0ED"/>
+                  <a:srgbClr val="38D39F"/>
                 </a:solidFill>
                 <a:latin typeface="IBM Plex Mono"/>
               </a:defRPr>
             </a:pPr>
             <a:r>
-              <a:t>VALIDACIÓN HONESTA · LO QUE ES CIERTO Y LO QUE FALTA</a:t>
+              <a:t>CIERRE DEL PITCH (MINUTO 3:00) · PEDIDO CONCRETO</a:t>
             </a:r>
           </a:p>
         </p:txBody>
@@ -7905,7 +7789,7 @@
         </p:nvSpPr>
         <p:spPr>
           <a:xfrm>
-            <a:off x="731520" y="822960"/>
+            <a:off x="731520" y="777240"/>
             <a:ext cx="10698480" cy="822960"/>
           </a:xfrm>
           <a:prstGeom prst="rect">
@@ -7920,7 +7804,7 @@
           <a:lstStyle/>
           <a:p>
             <a:pPr>
-              <a:defRPr sz="2800" b="1">
+              <a:defRPr sz="2700" b="1">
                 <a:solidFill>
                   <a:srgbClr val="F0F7FB"/>
                 </a:solidFill>
@@ -7928,20 +7812,15 @@
               </a:defRPr>
             </a:pPr>
             <a:r>
+              <a:t>EL FUTURO DE AUTHORY: </a:t>
+            </a:r>
+            <a:r>
               <a:rPr b="1">
                 <a:solidFill>
                   <a:srgbClr val="72E0ED"/>
                 </a:solidFill>
               </a:rPr>
-              <a:t>LO COMPROBADO</a:t>
-            </a:r>
-            <a:r>
-              <a:rPr b="1">
-                <a:solidFill>
-                  <a:srgbClr val="F0F7FB"/>
-                </a:solidFill>
-              </a:rPr>
-              <a:t> Y LO POR COMPROBAR</a:t>
+              <a:t>PEDIDO CONCRETO</a:t>
             </a:r>
           </a:p>
         </p:txBody>
@@ -7954,8 +7833,126 @@
         </p:nvSpPr>
         <p:spPr>
           <a:xfrm>
-            <a:off x="731520" y="1828800"/>
-            <a:ext cx="3383280" cy="4114800"/>
+            <a:off x="731520" y="1783080"/>
+            <a:ext cx="5212080" cy="3200400"/>
+          </a:xfrm>
+          <a:prstGeom prst="rect">
+            <a:avLst/>
+          </a:prstGeom>
+          <a:solidFill>
+            <a:srgbClr val="0D2744"/>
+          </a:solidFill>
+          <a:ln w="25400">
+            <a:solidFill>
+              <a:srgbClr val="0FAEC8"/>
+            </a:solidFill>
+          </a:ln>
+        </p:spPr>
+        <p:style>
+          <a:lnRef idx="1">
+            <a:schemeClr val="accent1"/>
+          </a:lnRef>
+          <a:fillRef idx="3">
+            <a:schemeClr val="accent1"/>
+          </a:fillRef>
+          <a:effectRef idx="2">
+            <a:schemeClr val="accent1"/>
+          </a:effectRef>
+          <a:fontRef idx="minor">
+            <a:schemeClr val="lt1"/>
+          </a:fontRef>
+        </p:style>
+        <p:txBody>
+          <a:bodyPr rtlCol="0" anchor="ctr"/>
+          <a:lstStyle/>
+          <a:p>
+            <a:pPr algn="ctr"/>
+          </a:p>
+        </p:txBody>
+      </p:sp>
+      <p:sp>
+        <p:nvSpPr>
+          <p:cNvPr id="6" name="TextBox 5"/>
+          <p:cNvSpPr txBox="1"/>
+          <p:nvPr/>
+        </p:nvSpPr>
+        <p:spPr>
+          <a:xfrm>
+            <a:off x="1005840" y="2011680"/>
+            <a:ext cx="4663440" cy="2743200"/>
+          </a:xfrm>
+          <a:prstGeom prst="rect">
+            <a:avLst/>
+          </a:prstGeom>
+          <a:noFill/>
+        </p:spPr>
+        <p:txBody>
+          <a:bodyPr wrap="square">
+            <a:spAutoFit/>
+          </a:bodyPr>
+          <a:lstStyle/>
+          <a:p>
+            <a:pPr>
+              <a:defRPr sz="1100" b="1">
+                <a:solidFill>
+                  <a:srgbClr val="0FAEC8"/>
+                </a:solidFill>
+                <a:latin typeface="IBM Plex Mono"/>
+              </a:defRPr>
+            </a:pPr>
+            <a:r>
+              <a:t>HOJA DE RUTA (PRÓXIMOS 30 DÍAS)</a:t>
+            </a:r>
+          </a:p>
+          <a:p>
+            <a:pPr>
+              <a:spcBef>
+                <a:spcPts val="600"/>
+              </a:spcBef>
+              <a:defRPr sz="1800" b="1">
+                <a:solidFill>
+                  <a:srgbClr val="F0F7FB"/>
+                </a:solidFill>
+                <a:latin typeface="Space Grotesk"/>
+              </a:defRPr>
+            </a:pPr>
+            <a:r>
+              <a:t>Hacia la Autocustodia Web3</a:t>
+            </a:r>
+          </a:p>
+          <a:p>
+            <a:pPr>
+              <a:spcBef>
+                <a:spcPts val="1000"/>
+              </a:spcBef>
+              <a:defRPr sz="1200">
+                <a:solidFill>
+                  <a:srgbClr val="8FB6D3"/>
+                </a:solidFill>
+                <a:latin typeface="IBM Plex Mono"/>
+              </a:defRPr>
+            </a:pPr>
+            <a:r>
+              <a:t>1. Integrar Stellar Wallets Kit (Freighter, xBull, Lobstr) para que cada autor firme transacciones con su propia clave privada.</a:t>
+            </a:r>
+            <a:br/>
+            <a:br/>
+            <a:r>
+              <a:t>2. Piloto controlado con 10 ilustradores independientes en Colombia y México.</a:t>
+            </a:r>
+          </a:p>
+        </p:txBody>
+      </p:sp>
+      <p:sp>
+        <p:nvSpPr>
+          <p:cNvPr id="7" name="Rectangle 6"/>
+          <p:cNvSpPr/>
+          <p:nvPr/>
+        </p:nvSpPr>
+        <p:spPr>
+          <a:xfrm>
+            <a:off x="6217920" y="1783080"/>
+            <a:ext cx="5212080" cy="3200400"/>
           </a:xfrm>
           <a:prstGeom prst="rect">
             <a:avLst/>
@@ -7993,14 +7990,14 @@
       </p:sp>
       <p:sp>
         <p:nvSpPr>
-          <p:cNvPr id="6" name="TextBox 5"/>
+          <p:cNvPr id="8" name="TextBox 7"/>
           <p:cNvSpPr txBox="1"/>
           <p:nvPr/>
         </p:nvSpPr>
         <p:spPr>
           <a:xfrm>
-            <a:off x="914400" y="2103120"/>
-            <a:ext cx="3017520" cy="3566160"/>
+            <a:off x="6492240" y="2011680"/>
+            <a:ext cx="4663440" cy="2743200"/>
           </a:xfrm>
           <a:prstGeom prst="rect">
             <a:avLst/>
@@ -8022,152 +8019,39 @@
               </a:defRPr>
             </a:pPr>
             <a:r>
-              <a:t>«CREEMOS»</a:t>
+              <a:t>PEDIDO CONCRETO AL JURADO Y MENTORES</a:t>
             </a:r>
           </a:p>
           <a:p>
             <a:pPr>
               <a:spcBef>
-                <a:spcPts val="800"/>
+                <a:spcPts val="600"/>
               </a:spcBef>
-              <a:defRPr sz="1700" b="1">
-                <a:solidFill>
-                  <a:srgbClr val="F0F7FB"/>
+              <a:defRPr sz="1800" b="1">
+                <a:solidFill>
+                  <a:srgbClr val="72E0ED"/>
                 </a:solidFill>
                 <a:latin typeface="Space Grotesk"/>
               </a:defRPr>
             </a:pPr>
             <a:r>
-              <a:t>HIPÓTESIS CRÍTICA</a:t>
+              <a:t>¿Cómo nos pueden apoyar hoy?</a:t>
             </a:r>
           </a:p>
           <a:p>
             <a:pPr>
               <a:spcBef>
-                <a:spcPts val="1200"/>
+                <a:spcPts val="1000"/>
               </a:spcBef>
-              <a:defRPr sz="1300">
-                <a:solidFill>
-                  <a:srgbClr val="8FB6D3"/>
+              <a:defRPr sz="1400" b="1">
+                <a:solidFill>
+                  <a:srgbClr val="F0F7FB"/>
                 </a:solidFill>
                 <a:latin typeface="IBM Plex Mono"/>
               </a:defRPr>
             </a:pPr>
             <a:r>
-              <a:t>4 de cada 5 ilustradores independientes incluirán un enlace verificable de Authory en sus presupuestos comerciales para protegerse del plagio.</a:t>
-            </a:r>
-          </a:p>
-        </p:txBody>
-      </p:sp>
-      <p:sp>
-        <p:nvSpPr>
-          <p:cNvPr id="7" name="Rectangle 6"/>
-          <p:cNvSpPr/>
-          <p:nvPr/>
-        </p:nvSpPr>
-        <p:spPr>
-          <a:xfrm>
-            <a:off x="4403750" y="1828800"/>
-            <a:ext cx="3383280" cy="4114800"/>
-          </a:xfrm>
-          <a:prstGeom prst="rect">
-            <a:avLst/>
-          </a:prstGeom>
-          <a:solidFill>
-            <a:srgbClr val="113459"/>
-          </a:solidFill>
-          <a:ln w="25400">
-            <a:solidFill>
-              <a:srgbClr val="0FAEC8"/>
-            </a:solidFill>
-          </a:ln>
-        </p:spPr>
-        <p:style>
-          <a:lnRef idx="1">
-            <a:schemeClr val="accent1"/>
-          </a:lnRef>
-          <a:fillRef idx="3">
-            <a:schemeClr val="accent1"/>
-          </a:fillRef>
-          <a:effectRef idx="2">
-            <a:schemeClr val="accent1"/>
-          </a:effectRef>
-          <a:fontRef idx="minor">
-            <a:schemeClr val="lt1"/>
-          </a:fontRef>
-        </p:style>
-        <p:txBody>
-          <a:bodyPr rtlCol="0" anchor="ctr"/>
-          <a:lstStyle/>
-          <a:p>
-            <a:pPr algn="ctr"/>
-          </a:p>
-        </p:txBody>
-      </p:sp>
-      <p:sp>
-        <p:nvSpPr>
-          <p:cNvPr id="8" name="TextBox 7"/>
-          <p:cNvSpPr txBox="1"/>
-          <p:nvPr/>
-        </p:nvSpPr>
-        <p:spPr>
-          <a:xfrm>
-            <a:off x="4586630" y="2103120"/>
-            <a:ext cx="3017520" cy="3566160"/>
-          </a:xfrm>
-          <a:prstGeom prst="rect">
-            <a:avLst/>
-          </a:prstGeom>
-          <a:noFill/>
-        </p:spPr>
-        <p:txBody>
-          <a:bodyPr wrap="square">
-            <a:spAutoFit/>
-          </a:bodyPr>
-          <a:lstStyle/>
-          <a:p>
-            <a:pPr>
-              <a:defRPr sz="1100" b="1">
-                <a:solidFill>
-                  <a:srgbClr val="0FAEC8"/>
-                </a:solidFill>
-                <a:latin typeface="IBM Plex Mono"/>
-              </a:defRPr>
-            </a:pPr>
-            <a:r>
-              <a:t>«OBSERVAMOS»</a:t>
-            </a:r>
-          </a:p>
-          <a:p>
-            <a:pPr>
-              <a:spcBef>
-                <a:spcPts val="800"/>
-              </a:spcBef>
-              <a:defRPr sz="1700" b="1">
-                <a:solidFill>
-                  <a:srgbClr val="F0F7FB"/>
-                </a:solidFill>
-                <a:latin typeface="Space Grotesk"/>
-              </a:defRPr>
-            </a:pPr>
-            <a:r>
-              <a:t>AJUSTE INTERNO</a:t>
-            </a:r>
-          </a:p>
-          <a:p>
-            <a:pPr>
-              <a:spcBef>
-                <a:spcPts val="1200"/>
-              </a:spcBef>
-              <a:defRPr sz="1300">
-                <a:solidFill>
-                  <a:srgbClr val="8FB6D3"/>
-                </a:solidFill>
-                <a:latin typeface="IBM Plex Mono"/>
-              </a:defRPr>
-            </a:pPr>
-            <a:r>
-              <a:t>Exigir wallet y gas en el onboarding expulsaba a creadores Web2. Ajustamos la UX para calcular SHA-256 en RAM instantáneamente sin barreras de entrada.</a:t>
+              <a:t>«Buscamos 5 agencias creativas y 10 creadores independientes que quieran proteger y certificar sus próximas 3 entregas comerciales con Authory.»</a:t>
             </a:r>
           </a:p>
         </p:txBody>
@@ -8180,14 +8064,14 @@
         </p:nvSpPr>
         <p:spPr>
           <a:xfrm>
-            <a:off x="8075980" y="1828800"/>
-            <a:ext cx="3383280" cy="4114800"/>
+            <a:off x="731520" y="5166360"/>
+            <a:ext cx="10728655" cy="868680"/>
           </a:xfrm>
           <a:prstGeom prst="rect">
             <a:avLst/>
           </a:prstGeom>
           <a:solidFill>
-            <a:srgbClr val="113459"/>
+            <a:srgbClr val="0D2744"/>
           </a:solidFill>
           <a:ln w="25400">
             <a:solidFill>
@@ -8225,8 +8109,8 @@
         </p:nvSpPr>
         <p:spPr>
           <a:xfrm>
-            <a:off x="8258860" y="2103120"/>
-            <a:ext cx="3017520" cy="3566160"/>
+            <a:off x="1005840" y="5257800"/>
+            <a:ext cx="10180015" cy="685800"/>
           </a:xfrm>
           <a:prstGeom prst="rect">
             <a:avLst/>
@@ -8240,7 +8124,7 @@
           <a:lstStyle/>
           <a:p>
             <a:pPr>
-              <a:defRPr sz="1100" b="1">
+              <a:defRPr sz="1000" b="1">
                 <a:solidFill>
                   <a:srgbClr val="38D39F"/>
                 </a:solidFill>
@@ -8248,15 +8132,15 @@
               </a:defRPr>
             </a:pPr>
             <a:r>
-              <a:t>«COMPROBAMOS»</a:t>
+              <a:t>🎙️ TRANSICIÓN A LA DEMO EN VIVO:</a:t>
             </a:r>
           </a:p>
           <a:p>
             <a:pPr>
               <a:spcBef>
-                <a:spcPts val="800"/>
+                <a:spcPts val="200"/>
               </a:spcBef>
-              <a:defRPr sz="1700" b="1">
+              <a:defRPr sz="1400" b="1">
                 <a:solidFill>
                   <a:srgbClr val="F0F7FB"/>
                 </a:solidFill>
@@ -8264,23 +8148,7 @@
               </a:defRPr>
             </a:pPr>
             <a:r>
-              <a:t>EVIDENCIA TÉCNICA</a:t>
-            </a:r>
-          </a:p>
-          <a:p>
-            <a:pPr>
-              <a:spcBef>
-                <a:spcPts val="1200"/>
-              </a:spcBef>
-              <a:defRPr sz="1300">
-                <a:solidFill>
-                  <a:srgbClr val="8FB6D3"/>
-                </a:solidFill>
-                <a:latin typeface="IBM Plex Mono"/>
-              </a:defRPr>
-            </a:pPr>
-            <a:r>
-              <a:t>Smart contract propio de 5 métodos en Soroban ejecutando atestaciones inmutables en menos de 3 segundos sobre Testnet con eventos nativos.</a:t>
+              <a:t>«Y para ver exactamente cómo lo vive Mateo en tiempo real, pasemos a nuestra demostración en vivo.»</a:t>
             </a:r>
           </a:p>
         </p:txBody>
@@ -8293,7 +8161,7 @@
         </p:nvSpPr>
         <p:spPr>
           <a:xfrm>
-            <a:off x="731520" y="6217920"/>
+            <a:off x="731520" y="6236208"/>
             <a:ext cx="10728655" cy="18288"/>
           </a:xfrm>
           <a:prstGeom prst="rect">
@@ -8338,7 +8206,7 @@
         </p:nvSpPr>
         <p:spPr>
           <a:xfrm>
-            <a:off x="731520" y="6291072"/>
+            <a:off x="731520" y="6309360"/>
             <a:ext cx="7772400" cy="320040"/>
           </a:xfrm>
           <a:prstGeom prst="rect">
@@ -8361,7 +8229,7 @@
               </a:defRPr>
             </a:pPr>
             <a:r>
-              <a:t>Decir con honestidad lo que falta no debilita la presentación: la hace creíble.</a:t>
+              <a:t>FIN DEL BLOQUE 1 (3:00 MIN) · PANTALLA COMPARTIDA DE LA DEMO</a:t>
             </a:r>
           </a:p>
         </p:txBody>
@@ -8374,7 +8242,7 @@
         </p:nvSpPr>
         <p:spPr>
           <a:xfrm>
-            <a:off x="8686800" y="6291072"/>
+            <a:off x="8686800" y="6309360"/>
             <a:ext cx="2773375" cy="320040"/>
           </a:xfrm>
           <a:prstGeom prst="rect">
@@ -8397,7 +8265,7 @@
               </a:defRPr>
             </a:pPr>
             <a:r>
-              <a:t>3:35 - 4:00 (25 s)</a:t>
+              <a:t>2:45 - 3:00 (15 s)</a:t>
             </a:r>
           </a:p>
         </p:txBody>
@@ -8473,7 +8341,7 @@
         </p:nvSpPr>
         <p:spPr>
           <a:xfrm>
-            <a:off x="731520" y="457200"/>
+            <a:off x="731520" y="411480"/>
             <a:ext cx="10698480" cy="365760"/>
           </a:xfrm>
           <a:prstGeom prst="rect">
@@ -8490,13 +8358,13 @@
             <a:pPr>
               <a:defRPr sz="1100" b="1">
                 <a:solidFill>
-                  <a:srgbClr val="38D39F"/>
+                  <a:srgbClr val="0FAEC8"/>
                 </a:solidFill>
                 <a:latin typeface="IBM Plex Mono"/>
               </a:defRPr>
             </a:pPr>
             <a:r>
-              <a:t>EL CIERRE DE LA HISTORIA · VOLVER AL USUARIO, NUNCA '¿PREGUNTAS?'</a:t>
+              <a:t>BLOQUE 2: DEMOSTRACIÓN EN VIVO · 2 MINUTOS COMPLETOS (3:00 - 5:00)</a:t>
             </a:r>
           </a:p>
         </p:txBody>
@@ -8509,7 +8377,7 @@
         </p:nvSpPr>
         <p:spPr>
           <a:xfrm>
-            <a:off x="731520" y="822960"/>
+            <a:off x="731520" y="777240"/>
             <a:ext cx="10698480" cy="822960"/>
           </a:xfrm>
           <a:prstGeom prst="rect">
@@ -8524,7 +8392,7 @@
           <a:lstStyle/>
           <a:p>
             <a:pPr>
-              <a:defRPr sz="2800" b="1">
+              <a:defRPr sz="2700" b="1">
                 <a:solidFill>
                   <a:srgbClr val="F0F7FB"/>
                 </a:solidFill>
@@ -8532,7 +8400,7 @@
               </a:defRPr>
             </a:pPr>
             <a:r>
-              <a:t>EL FUTURO DE AUTHORY: </a:t>
+              <a:t>UN SOLO FLUJO, </a:t>
             </a:r>
             <a:r>
               <a:rPr b="1">
@@ -8540,7 +8408,7 @@
                   <a:srgbClr val="72E0ED"/>
                 </a:solidFill>
               </a:rPr>
-              <a:t>PEDIDO CONCRETO</a:t>
+              <a:t>DE PUNTA A PUNTA</a:t>
             </a:r>
           </a:p>
         </p:txBody>
@@ -8553,14 +8421,14 @@
         </p:nvSpPr>
         <p:spPr>
           <a:xfrm>
-            <a:off x="731520" y="1828800"/>
-            <a:ext cx="5212080" cy="3108960"/>
+            <a:off x="731520" y="1783080"/>
+            <a:ext cx="2514600" cy="3017520"/>
           </a:xfrm>
           <a:prstGeom prst="rect">
             <a:avLst/>
           </a:prstGeom>
           <a:solidFill>
-            <a:srgbClr val="0D2744"/>
+            <a:srgbClr val="113459"/>
           </a:solidFill>
           <a:ln w="25400">
             <a:solidFill>
@@ -8598,8 +8466,8 @@
         </p:nvSpPr>
         <p:spPr>
           <a:xfrm>
-            <a:off x="1005840" y="2103120"/>
-            <a:ext cx="4663440" cy="2560320"/>
+            <a:off x="914400" y="1965960"/>
+            <a:ext cx="2148840" cy="2651760"/>
           </a:xfrm>
           <a:prstGeom prst="rect">
             <a:avLst/>
@@ -8613,7 +8481,7 @@
           <a:lstStyle/>
           <a:p>
             <a:pPr>
-              <a:defRPr sz="1100" b="1">
+              <a:defRPr sz="1000" b="1">
                 <a:solidFill>
                   <a:srgbClr val="0FAEC8"/>
                 </a:solidFill>
@@ -8621,7 +8489,7 @@
               </a:defRPr>
             </a:pPr>
             <a:r>
-              <a:t>HOJA DE RUTA (PRÓXIMOS 30 DÍAS)</a:t>
+              <a:t>0:00 - 0:30 (30 s)</a:t>
             </a:r>
           </a:p>
           <a:p>
@@ -8629,7 +8497,7 @@
               <a:spcBef>
                 <a:spcPts val="600"/>
               </a:spcBef>
-              <a:defRPr sz="1800" b="1">
+              <a:defRPr sz="1500" b="1">
                 <a:solidFill>
                   <a:srgbClr val="F0F7FB"/>
                 </a:solidFill>
@@ -8637,15 +8505,15 @@
               </a:defRPr>
             </a:pPr>
             <a:r>
-              <a:t>Hacia la Autocustodia Web3</a:t>
+              <a:t>1. HASH EN RAM</a:t>
             </a:r>
           </a:p>
           <a:p>
             <a:pPr>
               <a:spcBef>
-                <a:spcPts val="1000"/>
+                <a:spcPts val="800"/>
               </a:spcBef>
-              <a:defRPr sz="1200">
+              <a:defRPr sz="1100">
                 <a:solidFill>
                   <a:srgbClr val="8FB6D3"/>
                 </a:solidFill>
@@ -8653,12 +8521,7 @@
               </a:defRPr>
             </a:pPr>
             <a:r>
-              <a:t>1. Integrar Stellar Wallets Kit (Freighter, xBull, Lobstr) para que cada autor firme transacciones con su propia clave privada.</a:t>
-            </a:r>
-            <a:br/>
-            <a:br/>
-            <a:r>
-              <a:t>2. Lanzar piloto controlado con 10 ilustradores independientes en Colombia y México.</a:t>
+              <a:t>Mateo sube su obra. La Web Crypto API calcula el hash SHA-256 en su RAM. El archivo original jamás viaja a la red.</a:t>
             </a:r>
           </a:p>
         </p:txBody>
@@ -8671,8 +8534,234 @@
         </p:nvSpPr>
         <p:spPr>
           <a:xfrm>
-            <a:off x="6217920" y="1828800"/>
-            <a:ext cx="5212080" cy="3108960"/>
+            <a:off x="3465576" y="1783080"/>
+            <a:ext cx="2514600" cy="3017520"/>
+          </a:xfrm>
+          <a:prstGeom prst="rect">
+            <a:avLst/>
+          </a:prstGeom>
+          <a:solidFill>
+            <a:srgbClr val="113459"/>
+          </a:solidFill>
+          <a:ln w="25400">
+            <a:solidFill>
+              <a:srgbClr val="72E0ED"/>
+            </a:solidFill>
+          </a:ln>
+        </p:spPr>
+        <p:style>
+          <a:lnRef idx="1">
+            <a:schemeClr val="accent1"/>
+          </a:lnRef>
+          <a:fillRef idx="3">
+            <a:schemeClr val="accent1"/>
+          </a:fillRef>
+          <a:effectRef idx="2">
+            <a:schemeClr val="accent1"/>
+          </a:effectRef>
+          <a:fontRef idx="minor">
+            <a:schemeClr val="lt1"/>
+          </a:fontRef>
+        </p:style>
+        <p:txBody>
+          <a:bodyPr rtlCol="0" anchor="ctr"/>
+          <a:lstStyle/>
+          <a:p>
+            <a:pPr algn="ctr"/>
+          </a:p>
+        </p:txBody>
+      </p:sp>
+      <p:sp>
+        <p:nvSpPr>
+          <p:cNvPr id="8" name="TextBox 7"/>
+          <p:cNvSpPr txBox="1"/>
+          <p:nvPr/>
+        </p:nvSpPr>
+        <p:spPr>
+          <a:xfrm>
+            <a:off x="3648456" y="1965960"/>
+            <a:ext cx="2148840" cy="2651760"/>
+          </a:xfrm>
+          <a:prstGeom prst="rect">
+            <a:avLst/>
+          </a:prstGeom>
+          <a:noFill/>
+        </p:spPr>
+        <p:txBody>
+          <a:bodyPr wrap="square">
+            <a:spAutoFit/>
+          </a:bodyPr>
+          <a:lstStyle/>
+          <a:p>
+            <a:pPr>
+              <a:defRPr sz="1000" b="1">
+                <a:solidFill>
+                  <a:srgbClr val="72E0ED"/>
+                </a:solidFill>
+                <a:latin typeface="IBM Plex Mono"/>
+              </a:defRPr>
+            </a:pPr>
+            <a:r>
+              <a:t>0:30 - 1:00 (30 s)</a:t>
+            </a:r>
+          </a:p>
+          <a:p>
+            <a:pPr>
+              <a:spcBef>
+                <a:spcPts val="600"/>
+              </a:spcBef>
+              <a:defRPr sz="1500" b="1">
+                <a:solidFill>
+                  <a:srgbClr val="F0F7FB"/>
+                </a:solidFill>
+                <a:latin typeface="Space Grotesk"/>
+              </a:defRPr>
+            </a:pPr>
+            <a:r>
+              <a:t>2. SOROBAN</a:t>
+            </a:r>
+          </a:p>
+          <a:p>
+            <a:pPr>
+              <a:spcBef>
+                <a:spcPts val="800"/>
+              </a:spcBef>
+              <a:defRPr sz="1100">
+                <a:solidFill>
+                  <a:srgbClr val="8FB6D3"/>
+                </a:solidFill>
+                <a:latin typeface="IBM Plex Mono"/>
+              </a:defRPr>
+            </a:pPr>
+            <a:r>
+              <a:t>El smart contract en Stellar Testnet estampa la huella inmutable y emite el evento nativo work_reg.</a:t>
+            </a:r>
+          </a:p>
+        </p:txBody>
+      </p:sp>
+      <p:sp>
+        <p:nvSpPr>
+          <p:cNvPr id="9" name="Rectangle 8"/>
+          <p:cNvSpPr/>
+          <p:nvPr/>
+        </p:nvSpPr>
+        <p:spPr>
+          <a:xfrm>
+            <a:off x="6199632" y="1783080"/>
+            <a:ext cx="2514600" cy="3017520"/>
+          </a:xfrm>
+          <a:prstGeom prst="rect">
+            <a:avLst/>
+          </a:prstGeom>
+          <a:solidFill>
+            <a:srgbClr val="113459"/>
+          </a:solidFill>
+          <a:ln w="25400">
+            <a:solidFill>
+              <a:srgbClr val="38D39F"/>
+            </a:solidFill>
+          </a:ln>
+        </p:spPr>
+        <p:style>
+          <a:lnRef idx="1">
+            <a:schemeClr val="accent1"/>
+          </a:lnRef>
+          <a:fillRef idx="3">
+            <a:schemeClr val="accent1"/>
+          </a:fillRef>
+          <a:effectRef idx="2">
+            <a:schemeClr val="accent1"/>
+          </a:effectRef>
+          <a:fontRef idx="minor">
+            <a:schemeClr val="lt1"/>
+          </a:fontRef>
+        </p:style>
+        <p:txBody>
+          <a:bodyPr rtlCol="0" anchor="ctr"/>
+          <a:lstStyle/>
+          <a:p>
+            <a:pPr algn="ctr"/>
+          </a:p>
+        </p:txBody>
+      </p:sp>
+      <p:sp>
+        <p:nvSpPr>
+          <p:cNvPr id="10" name="TextBox 9"/>
+          <p:cNvSpPr txBox="1"/>
+          <p:nvPr/>
+        </p:nvSpPr>
+        <p:spPr>
+          <a:xfrm>
+            <a:off x="6382512" y="1965960"/>
+            <a:ext cx="2148840" cy="2651760"/>
+          </a:xfrm>
+          <a:prstGeom prst="rect">
+            <a:avLst/>
+          </a:prstGeom>
+          <a:noFill/>
+        </p:spPr>
+        <p:txBody>
+          <a:bodyPr wrap="square">
+            <a:spAutoFit/>
+          </a:bodyPr>
+          <a:lstStyle/>
+          <a:p>
+            <a:pPr>
+              <a:defRPr sz="1000" b="1">
+                <a:solidFill>
+                  <a:srgbClr val="38D39F"/>
+                </a:solidFill>
+                <a:latin typeface="IBM Plex Mono"/>
+              </a:defRPr>
+            </a:pPr>
+            <a:r>
+              <a:t>1:00 - 1:35 (35 s)</a:t>
+            </a:r>
+          </a:p>
+          <a:p>
+            <a:pPr>
+              <a:spcBef>
+                <a:spcPts val="600"/>
+              </a:spcBef>
+              <a:defRPr sz="1500" b="1">
+                <a:solidFill>
+                  <a:srgbClr val="F0F7FB"/>
+                </a:solidFill>
+                <a:latin typeface="Space Grotesk"/>
+              </a:defRPr>
+            </a:pPr>
+            <a:r>
+              <a:t>3. AUDITORÍA</a:t>
+            </a:r>
+          </a:p>
+          <a:p>
+            <a:pPr>
+              <a:spcBef>
+                <a:spcPts val="800"/>
+              </a:spcBef>
+              <a:defRPr sz="1100">
+                <a:solidFill>
+                  <a:srgbClr val="8FB6D3"/>
+                </a:solidFill>
+                <a:latin typeface="IBM Plex Mono"/>
+              </a:defRPr>
+            </a:pPr>
+            <a:r>
+              <a:t>La editorial entra a /verificar, sube el archivo recibido y comprueba autoría y precedencia en &lt;3 s sin tener cuenta.</a:t>
+            </a:r>
+          </a:p>
+        </p:txBody>
+      </p:sp>
+      <p:sp>
+        <p:nvSpPr>
+          <p:cNvPr id="11" name="Rectangle 10"/>
+          <p:cNvSpPr/>
+          <p:nvPr/>
+        </p:nvSpPr>
+        <p:spPr>
+          <a:xfrm>
+            <a:off x="8933688" y="1783080"/>
+            <a:ext cx="2514600" cy="3017520"/>
           </a:xfrm>
           <a:prstGeom prst="rect">
             <a:avLst/>
@@ -8710,14 +8799,14 @@
       </p:sp>
       <p:sp>
         <p:nvSpPr>
-          <p:cNvPr id="8" name="TextBox 7"/>
+          <p:cNvPr id="12" name="TextBox 11"/>
           <p:cNvSpPr txBox="1"/>
           <p:nvPr/>
         </p:nvSpPr>
         <p:spPr>
           <a:xfrm>
-            <a:off x="6492240" y="2103120"/>
-            <a:ext cx="4663440" cy="2560320"/>
+            <a:off x="9116568" y="1965960"/>
+            <a:ext cx="2148840" cy="2651760"/>
           </a:xfrm>
           <a:prstGeom prst="rect">
             <a:avLst/>
@@ -8731,7 +8820,7 @@
           <a:lstStyle/>
           <a:p>
             <a:pPr>
-              <a:defRPr sz="1100" b="1">
+              <a:defRPr sz="1000" b="1">
                 <a:solidFill>
                   <a:srgbClr val="F97316"/>
                 </a:solidFill>
@@ -8739,7 +8828,7 @@
               </a:defRPr>
             </a:pPr>
             <a:r>
-              <a:t>PEDIDO CONCRETO AL JURADO Y MENTORES</a:t>
+              <a:t>1:35 - 2:00 (25 s)</a:t>
             </a:r>
           </a:p>
           <a:p>
@@ -8747,45 +8836,45 @@
               <a:spcBef>
                 <a:spcPts val="600"/>
               </a:spcBef>
-              <a:defRPr sz="1800" b="1">
-                <a:solidFill>
-                  <a:srgbClr val="72E0ED"/>
+              <a:defRPr sz="1500" b="1">
+                <a:solidFill>
+                  <a:srgbClr val="F0F7FB"/>
                 </a:solidFill>
                 <a:latin typeface="Space Grotesk"/>
               </a:defRPr>
             </a:pPr>
             <a:r>
-              <a:t>¿Cómo nos pueden apoyar hoy?</a:t>
+              <a:t>4. COMPROBANTE</a:t>
             </a:r>
           </a:p>
           <a:p>
             <a:pPr>
               <a:spcBef>
-                <a:spcPts val="1000"/>
+                <a:spcPts val="800"/>
               </a:spcBef>
-              <a:defRPr sz="1400" b="1">
-                <a:solidFill>
-                  <a:srgbClr val="F0F7FB"/>
+              <a:defRPr sz="1100">
+                <a:solidFill>
+                  <a:srgbClr val="8FB6D3"/>
                 </a:solidFill>
                 <a:latin typeface="IBM Plex Mono"/>
               </a:defRPr>
             </a:pPr>
             <a:r>
-              <a:t>«Buscamos 5 agencias creativas y 10 creadores independientes que quieran proteger y certificar sus próximas 3 entregas comerciales con Authory.»</a:t>
-            </a:r>
-          </a:p>
-        </p:txBody>
-      </p:sp>
-      <p:sp>
-        <p:nvSpPr>
-          <p:cNvPr id="9" name="Rectangle 8"/>
+              <a:t>Inspección pública del ledger en Stellar Expert: evento y bloque consultable por terceros.</a:t>
+            </a:r>
+          </a:p>
+        </p:txBody>
+      </p:sp>
+      <p:sp>
+        <p:nvSpPr>
+          <p:cNvPr id="13" name="Rectangle 12"/>
           <p:cNvSpPr/>
           <p:nvPr/>
         </p:nvSpPr>
         <p:spPr>
           <a:xfrm>
-            <a:off x="731520" y="5120640"/>
-            <a:ext cx="10728655" cy="868680"/>
+            <a:off x="731520" y="4983480"/>
+            <a:ext cx="10728655" cy="1051560"/>
           </a:xfrm>
           <a:prstGeom prst="rect">
             <a:avLst/>
@@ -8795,7 +8884,7 @@
           </a:solidFill>
           <a:ln w="25400">
             <a:solidFill>
-              <a:srgbClr val="38D39F"/>
+              <a:srgbClr val="1A4975"/>
             </a:solidFill>
           </a:ln>
         </p:spPr>
@@ -8823,14 +8912,14 @@
       </p:sp>
       <p:sp>
         <p:nvSpPr>
-          <p:cNvPr id="10" name="TextBox 9"/>
+          <p:cNvPr id="14" name="TextBox 13"/>
           <p:cNvSpPr txBox="1"/>
           <p:nvPr/>
         </p:nvSpPr>
         <p:spPr>
           <a:xfrm>
-            <a:off x="1005840" y="5257800"/>
-            <a:ext cx="10180015" cy="640080"/>
+            <a:off x="1005840" y="5074920"/>
+            <a:ext cx="10180015" cy="868680"/>
           </a:xfrm>
           <a:prstGeom prst="rect">
             <a:avLst/>
@@ -8844,44 +8933,44 @@
           <a:lstStyle/>
           <a:p>
             <a:pPr>
-              <a:defRPr sz="1000" b="1">
-                <a:solidFill>
-                  <a:srgbClr val="38D39F"/>
+              <a:defRPr sz="1100" b="1">
+                <a:solidFill>
+                  <a:srgbClr val="72E0ED"/>
                 </a:solidFill>
                 <a:latin typeface="IBM Plex Mono"/>
               </a:defRPr>
             </a:pPr>
             <a:r>
-              <a:t>🎨 LA ÚLTIMA IMAGEN NO ES UN CONTRATO NI UN CÓDIGO:</a:t>
+              <a:t>⚠️ PROTOCOLO PLAN B EN CASO DE CONTINGENCIA:</a:t>
             </a:r>
           </a:p>
           <a:p>
             <a:pPr>
               <a:spcBef>
-                <a:spcPts val="200"/>
+                <a:spcPts val="300"/>
               </a:spcBef>
-              <a:defRPr sz="1400" b="1">
+              <a:defRPr sz="1200">
                 <a:solidFill>
                   <a:srgbClr val="F0F7FB"/>
                 </a:solidFill>
-                <a:latin typeface="Space Grotesk"/>
-              </a:defRPr>
-            </a:pPr>
-            <a:r>
-              <a:t>Es Mateo cobrando su trabajo a tiempo y la editorial publicando con total tranquilidad jurídica.</a:t>
-            </a:r>
-          </a:p>
-        </p:txBody>
-      </p:sp>
-      <p:sp>
-        <p:nvSpPr>
-          <p:cNvPr id="11" name="Rectangle 10"/>
+                <a:latin typeface="IBM Plex Mono"/>
+              </a:defRPr>
+            </a:pPr>
+            <a:r>
+              <a:t>Si Soroban tarda &gt;10 s, pasar a pestaña de Stellar Expert con la transacción confirmada. Si falla la red, video de YouTube (1:15). | App en vivo: authority-khaki.vercel.app</a:t>
+            </a:r>
+          </a:p>
+        </p:txBody>
+      </p:sp>
+      <p:sp>
+        <p:nvSpPr>
+          <p:cNvPr id="15" name="Rectangle 14"/>
           <p:cNvSpPr/>
           <p:nvPr/>
         </p:nvSpPr>
         <p:spPr>
           <a:xfrm>
-            <a:off x="731520" y="6217920"/>
+            <a:off x="731520" y="6236208"/>
             <a:ext cx="10728655" cy="18288"/>
           </a:xfrm>
           <a:prstGeom prst="rect">
@@ -8920,13 +9009,661 @@
       </p:sp>
       <p:sp>
         <p:nvSpPr>
+          <p:cNvPr id="16" name="TextBox 15"/>
+          <p:cNvSpPr txBox="1"/>
+          <p:nvPr/>
+        </p:nvSpPr>
+        <p:spPr>
+          <a:xfrm>
+            <a:off x="731520" y="6309360"/>
+            <a:ext cx="7772400" cy="320040"/>
+          </a:xfrm>
+          <a:prstGeom prst="rect">
+            <a:avLst/>
+          </a:prstGeom>
+          <a:noFill/>
+        </p:spPr>
+        <p:txBody>
+          <a:bodyPr wrap="square" lIns="0" tIns="0" rIns="0" bIns="0">
+            <a:spAutoFit/>
+          </a:bodyPr>
+          <a:lstStyle/>
+          <a:p>
+            <a:pPr>
+              <a:defRPr sz="1100">
+                <a:solidFill>
+                  <a:srgbClr val="8FB6D3"/>
+                </a:solidFill>
+                <a:latin typeface="IBM Plex Mono"/>
+              </a:defRPr>
+            </a:pPr>
+            <a:r>
+              <a:t>REGLA: El driver ejecuta en silencio; el orador narra resultados y valor para Mateo.</a:t>
+            </a:r>
+          </a:p>
+        </p:txBody>
+      </p:sp>
+      <p:sp>
+        <p:nvSpPr>
+          <p:cNvPr id="17" name="TextBox 16"/>
+          <p:cNvSpPr txBox="1"/>
+          <p:nvPr/>
+        </p:nvSpPr>
+        <p:spPr>
+          <a:xfrm>
+            <a:off x="8686800" y="6309360"/>
+            <a:ext cx="2773375" cy="320040"/>
+          </a:xfrm>
+          <a:prstGeom prst="rect">
+            <a:avLst/>
+          </a:prstGeom>
+          <a:noFill/>
+        </p:spPr>
+        <p:txBody>
+          <a:bodyPr wrap="square" lIns="0" tIns="0" rIns="0" bIns="0">
+            <a:spAutoFit/>
+          </a:bodyPr>
+          <a:lstStyle/>
+          <a:p>
+            <a:pPr algn="r">
+              <a:defRPr sz="1100" b="1">
+                <a:solidFill>
+                  <a:srgbClr val="72E0ED"/>
+                </a:solidFill>
+                <a:latin typeface="IBM Plex Mono"/>
+              </a:defRPr>
+            </a:pPr>
+            <a:r>
+              <a:t>3:00 - 5:00 (2:00 min)</a:t>
+            </a:r>
+          </a:p>
+        </p:txBody>
+      </p:sp>
+    </p:spTree>
+  </p:cSld>
+  <p:clrMapOvr>
+    <a:masterClrMapping/>
+  </p:clrMapOvr>
+</p:sld>
+</file>
+
+<file path=ppt/slides/slide9.xml><?xml version="1.0" encoding="utf-8"?>
+<p:sld xmlns:a="http://schemas.openxmlformats.org/drawingml/2006/main" xmlns:p="http://schemas.openxmlformats.org/presentationml/2006/main" xmlns:r="http://schemas.openxmlformats.org/officeDocument/2006/relationships">
+  <p:cSld>
+    <p:spTree>
+      <p:nvGrpSpPr>
+        <p:cNvPr id="1" name=""/>
+        <p:cNvGrpSpPr/>
+        <p:nvPr/>
+      </p:nvGrpSpPr>
+      <p:grpSpPr/>
+      <p:sp>
+        <p:nvSpPr>
+          <p:cNvPr id="2" name="Rectangle 1"/>
+          <p:cNvSpPr/>
+          <p:nvPr/>
+        </p:nvSpPr>
+        <p:spPr>
+          <a:xfrm>
+            <a:off x="0" y="0"/>
+            <a:ext cx="12191695" cy="6858000"/>
+          </a:xfrm>
+          <a:prstGeom prst="rect">
+            <a:avLst/>
+          </a:prstGeom>
+          <a:solidFill>
+            <a:srgbClr val="071F38"/>
+          </a:solidFill>
+          <a:ln>
+            <a:solidFill>
+              <a:srgbClr val="071F38"/>
+            </a:solidFill>
+          </a:ln>
+        </p:spPr>
+        <p:style>
+          <a:lnRef idx="1">
+            <a:schemeClr val="accent1"/>
+          </a:lnRef>
+          <a:fillRef idx="3">
+            <a:schemeClr val="accent1"/>
+          </a:fillRef>
+          <a:effectRef idx="2">
+            <a:schemeClr val="accent1"/>
+          </a:effectRef>
+          <a:fontRef idx="minor">
+            <a:schemeClr val="lt1"/>
+          </a:fontRef>
+        </p:style>
+        <p:txBody>
+          <a:bodyPr rtlCol="0" anchor="ctr"/>
+          <a:lstStyle/>
+          <a:p>
+            <a:pPr algn="ctr"/>
+          </a:p>
+        </p:txBody>
+      </p:sp>
+      <p:sp>
+        <p:nvSpPr>
+          <p:cNvPr id="3" name="TextBox 2"/>
+          <p:cNvSpPr txBox="1"/>
+          <p:nvPr/>
+        </p:nvSpPr>
+        <p:spPr>
+          <a:xfrm>
+            <a:off x="731520" y="411480"/>
+            <a:ext cx="10698480" cy="365760"/>
+          </a:xfrm>
+          <a:prstGeom prst="rect">
+            <a:avLst/>
+          </a:prstGeom>
+          <a:noFill/>
+        </p:spPr>
+        <p:txBody>
+          <a:bodyPr wrap="square" lIns="0" tIns="0" rIns="0" bIns="0">
+            <a:spAutoFit/>
+          </a:bodyPr>
+          <a:lstStyle/>
+          <a:p>
+            <a:pPr>
+              <a:defRPr sz="1100" b="1">
+                <a:solidFill>
+                  <a:srgbClr val="38D39F"/>
+                </a:solidFill>
+                <a:latin typeface="IBM Plex Mono"/>
+              </a:defRPr>
+            </a:pPr>
+            <a:r>
+              <a:t>BLOQUE 3: PREGUNTAS DEL JURADO · 2 MINUTOS (5:00 - 7:00)</a:t>
+            </a:r>
+          </a:p>
+        </p:txBody>
+      </p:sp>
+      <p:sp>
+        <p:nvSpPr>
+          <p:cNvPr id="4" name="TextBox 3"/>
+          <p:cNvSpPr txBox="1"/>
+          <p:nvPr/>
+        </p:nvSpPr>
+        <p:spPr>
+          <a:xfrm>
+            <a:off x="731520" y="777240"/>
+            <a:ext cx="10698480" cy="822960"/>
+          </a:xfrm>
+          <a:prstGeom prst="rect">
+            <a:avLst/>
+          </a:prstGeom>
+          <a:noFill/>
+        </p:spPr>
+        <p:txBody>
+          <a:bodyPr wrap="square" lIns="0" tIns="0" rIns="0" bIns="0">
+            <a:spAutoFit/>
+          </a:bodyPr>
+          <a:lstStyle/>
+          <a:p>
+            <a:pPr>
+              <a:defRPr sz="2700" b="1">
+                <a:solidFill>
+                  <a:srgbClr val="F0F7FB"/>
+                </a:solidFill>
+                <a:latin typeface="Space Grotesk"/>
+              </a:defRPr>
+            </a:pPr>
+            <a:r>
+              <a:t>BANCO DE RESPUESTAS: </a:t>
+            </a:r>
+            <a:r>
+              <a:rPr b="1">
+                <a:solidFill>
+                  <a:srgbClr val="72E0ED"/>
+                </a:solidFill>
+              </a:rPr>
+              <a:t>Q&amp;A DEL JURADO</a:t>
+            </a:r>
+          </a:p>
+        </p:txBody>
+      </p:sp>
+      <p:sp>
+        <p:nvSpPr>
+          <p:cNvPr id="5" name="Rectangle 4"/>
+          <p:cNvSpPr/>
+          <p:nvPr/>
+        </p:nvSpPr>
+        <p:spPr>
+          <a:xfrm>
+            <a:off x="731520" y="1783080"/>
+            <a:ext cx="5212080" cy="2011680"/>
+          </a:xfrm>
+          <a:prstGeom prst="rect">
+            <a:avLst/>
+          </a:prstGeom>
+          <a:solidFill>
+            <a:srgbClr val="113459"/>
+          </a:solidFill>
+          <a:ln w="25400">
+            <a:solidFill>
+              <a:srgbClr val="0FAEC8"/>
+            </a:solidFill>
+          </a:ln>
+        </p:spPr>
+        <p:style>
+          <a:lnRef idx="1">
+            <a:schemeClr val="accent1"/>
+          </a:lnRef>
+          <a:fillRef idx="3">
+            <a:schemeClr val="accent1"/>
+          </a:fillRef>
+          <a:effectRef idx="2">
+            <a:schemeClr val="accent1"/>
+          </a:effectRef>
+          <a:fontRef idx="minor">
+            <a:schemeClr val="lt1"/>
+          </a:fontRef>
+        </p:style>
+        <p:txBody>
+          <a:bodyPr rtlCol="0" anchor="ctr"/>
+          <a:lstStyle/>
+          <a:p>
+            <a:pPr algn="ctr"/>
+          </a:p>
+        </p:txBody>
+      </p:sp>
+      <p:sp>
+        <p:nvSpPr>
+          <p:cNvPr id="6" name="TextBox 5"/>
+          <p:cNvSpPr txBox="1"/>
+          <p:nvPr/>
+        </p:nvSpPr>
+        <p:spPr>
+          <a:xfrm>
+            <a:off x="914400" y="1920240"/>
+            <a:ext cx="4846320" cy="1737360"/>
+          </a:xfrm>
+          <a:prstGeom prst="rect">
+            <a:avLst/>
+          </a:prstGeom>
+          <a:noFill/>
+        </p:spPr>
+        <p:txBody>
+          <a:bodyPr wrap="square">
+            <a:spAutoFit/>
+          </a:bodyPr>
+          <a:lstStyle/>
+          <a:p>
+            <a:pPr>
+              <a:defRPr sz="1100" b="1">
+                <a:solidFill>
+                  <a:srgbClr val="0FAEC8"/>
+                </a:solidFill>
+                <a:latin typeface="IBM Plex Mono"/>
+              </a:defRPr>
+            </a:pPr>
+            <a:r>
+              <a:t>P1: ¿POR QUÉ NO POSTGRESQL / BASE DE DATOS TRADICIONAL?</a:t>
+            </a:r>
+          </a:p>
+          <a:p>
+            <a:pPr>
+              <a:spcBef>
+                <a:spcPts val="600"/>
+              </a:spcBef>
+              <a:defRPr sz="1150">
+                <a:solidFill>
+                  <a:srgbClr val="F0F7FB"/>
+                </a:solidFill>
+                <a:latin typeface="IBM Plex Mono"/>
+              </a:defRPr>
+            </a:pPr>
+            <a:r>
+              <a:t>Respuesta: En una base de datos tradicional, la validez depende de confiar en el administrador del servidor. En Stellar, el registro es descentralizado, inmutable e independiente de la empresa, con comisiones de &lt;$0.001 USD.</a:t>
+            </a:r>
+          </a:p>
+        </p:txBody>
+      </p:sp>
+      <p:sp>
+        <p:nvSpPr>
+          <p:cNvPr id="7" name="Rectangle 6"/>
+          <p:cNvSpPr/>
+          <p:nvPr/>
+        </p:nvSpPr>
+        <p:spPr>
+          <a:xfrm>
+            <a:off x="6248095" y="1783080"/>
+            <a:ext cx="5212080" cy="2011680"/>
+          </a:xfrm>
+          <a:prstGeom prst="rect">
+            <a:avLst/>
+          </a:prstGeom>
+          <a:solidFill>
+            <a:srgbClr val="113459"/>
+          </a:solidFill>
+          <a:ln w="25400">
+            <a:solidFill>
+              <a:srgbClr val="F97316"/>
+            </a:solidFill>
+          </a:ln>
+        </p:spPr>
+        <p:style>
+          <a:lnRef idx="1">
+            <a:schemeClr val="accent1"/>
+          </a:lnRef>
+          <a:fillRef idx="3">
+            <a:schemeClr val="accent1"/>
+          </a:fillRef>
+          <a:effectRef idx="2">
+            <a:schemeClr val="accent1"/>
+          </a:effectRef>
+          <a:fontRef idx="minor">
+            <a:schemeClr val="lt1"/>
+          </a:fontRef>
+        </p:style>
+        <p:txBody>
+          <a:bodyPr rtlCol="0" anchor="ctr"/>
+          <a:lstStyle/>
+          <a:p>
+            <a:pPr algn="ctr"/>
+          </a:p>
+        </p:txBody>
+      </p:sp>
+      <p:sp>
+        <p:nvSpPr>
+          <p:cNvPr id="8" name="TextBox 7"/>
+          <p:cNvSpPr txBox="1"/>
+          <p:nvPr/>
+        </p:nvSpPr>
+        <p:spPr>
+          <a:xfrm>
+            <a:off x="6430975" y="1920240"/>
+            <a:ext cx="4846320" cy="1737360"/>
+          </a:xfrm>
+          <a:prstGeom prst="rect">
+            <a:avLst/>
+          </a:prstGeom>
+          <a:noFill/>
+        </p:spPr>
+        <p:txBody>
+          <a:bodyPr wrap="square">
+            <a:spAutoFit/>
+          </a:bodyPr>
+          <a:lstStyle/>
+          <a:p>
+            <a:pPr>
+              <a:defRPr sz="1100" b="1">
+                <a:solidFill>
+                  <a:srgbClr val="F97316"/>
+                </a:solidFill>
+                <a:latin typeface="IBM Plex Mono"/>
+              </a:defRPr>
+            </a:pPr>
+            <a:r>
+              <a:t>P2: ¿Y SI ALGUIEN REGISTRA UNA OBRA QUE NO ES SUYA?</a:t>
+            </a:r>
+          </a:p>
+          <a:p>
+            <a:pPr>
+              <a:spcBef>
+                <a:spcPts val="600"/>
+              </a:spcBef>
+              <a:defRPr sz="1150">
+                <a:solidFill>
+                  <a:srgbClr val="F0F7FB"/>
+                </a:solidFill>
+                <a:latin typeface="IBM Plex Mono"/>
+              </a:defRPr>
+            </a:pPr>
+            <a:r>
+              <a:t>Respuesta: La red garantiza la precedencia temporal matemática en un momento del tiempo, no la verdad física. Mateo obtiene una prueba irrefutable de posesión anterior que desmiente cualquier intento de registro posterior.</a:t>
+            </a:r>
+          </a:p>
+        </p:txBody>
+      </p:sp>
+      <p:sp>
+        <p:nvSpPr>
+          <p:cNvPr id="9" name="Rectangle 8"/>
+          <p:cNvSpPr/>
+          <p:nvPr/>
+        </p:nvSpPr>
+        <p:spPr>
+          <a:xfrm>
+            <a:off x="731520" y="3931920"/>
+            <a:ext cx="5212080" cy="2011680"/>
+          </a:xfrm>
+          <a:prstGeom prst="rect">
+            <a:avLst/>
+          </a:prstGeom>
+          <a:solidFill>
+            <a:srgbClr val="113459"/>
+          </a:solidFill>
+          <a:ln w="25400">
+            <a:solidFill>
+              <a:srgbClr val="1A4975"/>
+            </a:solidFill>
+          </a:ln>
+        </p:spPr>
+        <p:style>
+          <a:lnRef idx="1">
+            <a:schemeClr val="accent1"/>
+          </a:lnRef>
+          <a:fillRef idx="3">
+            <a:schemeClr val="accent1"/>
+          </a:fillRef>
+          <a:effectRef idx="2">
+            <a:schemeClr val="accent1"/>
+          </a:effectRef>
+          <a:fontRef idx="minor">
+            <a:schemeClr val="lt1"/>
+          </a:fontRef>
+        </p:style>
+        <p:txBody>
+          <a:bodyPr rtlCol="0" anchor="ctr"/>
+          <a:lstStyle/>
+          <a:p>
+            <a:pPr algn="ctr"/>
+          </a:p>
+        </p:txBody>
+      </p:sp>
+      <p:sp>
+        <p:nvSpPr>
+          <p:cNvPr id="10" name="TextBox 9"/>
+          <p:cNvSpPr txBox="1"/>
+          <p:nvPr/>
+        </p:nvSpPr>
+        <p:spPr>
+          <a:xfrm>
+            <a:off x="914400" y="4069080"/>
+            <a:ext cx="4846320" cy="1737360"/>
+          </a:xfrm>
+          <a:prstGeom prst="rect">
+            <a:avLst/>
+          </a:prstGeom>
+          <a:noFill/>
+        </p:spPr>
+        <p:txBody>
+          <a:bodyPr wrap="square">
+            <a:spAutoFit/>
+          </a:bodyPr>
+          <a:lstStyle/>
+          <a:p>
+            <a:pPr>
+              <a:defRPr sz="1100" b="1">
+                <a:solidFill>
+                  <a:srgbClr val="1A4975"/>
+                </a:solidFill>
+                <a:latin typeface="IBM Plex Mono"/>
+              </a:defRPr>
+            </a:pPr>
+            <a:r>
+              <a:t>P3: ¿CUÁNTO CUESTA Y QUIÉN PAGA EL GAS?</a:t>
+            </a:r>
+          </a:p>
+          <a:p>
+            <a:pPr>
+              <a:spcBef>
+                <a:spcPts val="600"/>
+              </a:spcBef>
+              <a:defRPr sz="1150">
+                <a:solidFill>
+                  <a:srgbClr val="F0F7FB"/>
+                </a:solidFill>
+                <a:latin typeface="IBM Plex Mono"/>
+              </a:defRPr>
+            </a:pPr>
+            <a:r>
+              <a:t>Respuesta: Fracciones de centavo. En onboarding, Authory subsidia las transacciones con cuentas operativas para usuarios Web2; en fase avanzada cada usuario o agencia firma con su propia wallet.</a:t>
+            </a:r>
+          </a:p>
+        </p:txBody>
+      </p:sp>
+      <p:sp>
+        <p:nvSpPr>
+          <p:cNvPr id="11" name="Rectangle 10"/>
+          <p:cNvSpPr/>
+          <p:nvPr/>
+        </p:nvSpPr>
+        <p:spPr>
+          <a:xfrm>
+            <a:off x="6248095" y="3931920"/>
+            <a:ext cx="5212080" cy="2011680"/>
+          </a:xfrm>
+          <a:prstGeom prst="rect">
+            <a:avLst/>
+          </a:prstGeom>
+          <a:solidFill>
+            <a:srgbClr val="113459"/>
+          </a:solidFill>
+          <a:ln w="25400">
+            <a:solidFill>
+              <a:srgbClr val="38D39F"/>
+            </a:solidFill>
+          </a:ln>
+        </p:spPr>
+        <p:style>
+          <a:lnRef idx="1">
+            <a:schemeClr val="accent1"/>
+          </a:lnRef>
+          <a:fillRef idx="3">
+            <a:schemeClr val="accent1"/>
+          </a:fillRef>
+          <a:effectRef idx="2">
+            <a:schemeClr val="accent1"/>
+          </a:effectRef>
+          <a:fontRef idx="minor">
+            <a:schemeClr val="lt1"/>
+          </a:fontRef>
+        </p:style>
+        <p:txBody>
+          <a:bodyPr rtlCol="0" anchor="ctr"/>
+          <a:lstStyle/>
+          <a:p>
+            <a:pPr algn="ctr"/>
+          </a:p>
+        </p:txBody>
+      </p:sp>
+      <p:sp>
+        <p:nvSpPr>
           <p:cNvPr id="12" name="TextBox 11"/>
           <p:cNvSpPr txBox="1"/>
           <p:nvPr/>
         </p:nvSpPr>
         <p:spPr>
           <a:xfrm>
-            <a:off x="731520" y="6291072"/>
+            <a:off x="6430975" y="4069080"/>
+            <a:ext cx="4846320" cy="1737360"/>
+          </a:xfrm>
+          <a:prstGeom prst="rect">
+            <a:avLst/>
+          </a:prstGeom>
+          <a:noFill/>
+        </p:spPr>
+        <p:txBody>
+          <a:bodyPr wrap="square">
+            <a:spAutoFit/>
+          </a:bodyPr>
+          <a:lstStyle/>
+          <a:p>
+            <a:pPr>
+              <a:defRPr sz="1100" b="1">
+                <a:solidFill>
+                  <a:srgbClr val="38D39F"/>
+                </a:solidFill>
+                <a:latin typeface="IBM Plex Mono"/>
+              </a:defRPr>
+            </a:pPr>
+            <a:r>
+              <a:t>P4: ¿CÓMO SE PROTEGE EL ARCHIVO ORIGINAL?</a:t>
+            </a:r>
+          </a:p>
+          <a:p>
+            <a:pPr>
+              <a:spcBef>
+                <a:spcPts val="600"/>
+              </a:spcBef>
+              <a:defRPr sz="1150">
+                <a:solidFill>
+                  <a:srgbClr val="F0F7FB"/>
+                </a:solidFill>
+                <a:latin typeface="IBM Plex Mono"/>
+              </a:defRPr>
+            </a:pPr>
+            <a:r>
+              <a:t>Respuesta: El archivo nunca sube a la red. La Web Crypto API calcula el hash SHA-256 en RAM. Es matemáticamente imposible reconstruir el archivo desde el hash; la privacidad es 100% off-chain.</a:t>
+            </a:r>
+          </a:p>
+        </p:txBody>
+      </p:sp>
+      <p:sp>
+        <p:nvSpPr>
+          <p:cNvPr id="13" name="Rectangle 12"/>
+          <p:cNvSpPr/>
+          <p:nvPr/>
+        </p:nvSpPr>
+        <p:spPr>
+          <a:xfrm>
+            <a:off x="731520" y="6236208"/>
+            <a:ext cx="10728655" cy="18288"/>
+          </a:xfrm>
+          <a:prstGeom prst="rect">
+            <a:avLst/>
+          </a:prstGeom>
+          <a:solidFill>
+            <a:srgbClr val="1A4975"/>
+          </a:solidFill>
+          <a:ln>
+            <a:solidFill>
+              <a:srgbClr val="1A4975"/>
+            </a:solidFill>
+          </a:ln>
+        </p:spPr>
+        <p:style>
+          <a:lnRef idx="1">
+            <a:schemeClr val="accent1"/>
+          </a:lnRef>
+          <a:fillRef idx="3">
+            <a:schemeClr val="accent1"/>
+          </a:fillRef>
+          <a:effectRef idx="2">
+            <a:schemeClr val="accent1"/>
+          </a:effectRef>
+          <a:fontRef idx="minor">
+            <a:schemeClr val="lt1"/>
+          </a:fontRef>
+        </p:style>
+        <p:txBody>
+          <a:bodyPr rtlCol="0" anchor="ctr"/>
+          <a:lstStyle/>
+          <a:p>
+            <a:pPr algn="ctr"/>
+          </a:p>
+        </p:txBody>
+      </p:sp>
+      <p:sp>
+        <p:nvSpPr>
+          <p:cNvPr id="14" name="TextBox 13"/>
+          <p:cNvSpPr txBox="1"/>
+          <p:nvPr/>
+        </p:nvSpPr>
+        <p:spPr>
+          <a:xfrm>
+            <a:off x="731520" y="6309360"/>
             <a:ext cx="7772400" cy="320040"/>
           </a:xfrm>
           <a:prstGeom prst="rect">
@@ -8949,20 +9686,20 @@
               </a:defRPr>
             </a:pPr>
             <a:r>
-              <a:t>¡MUCHAS GRACIAS! · github.com/nidaela/Authory</a:t>
-            </a:r>
-          </a:p>
-        </p:txBody>
-      </p:sp>
-      <p:sp>
-        <p:nvSpPr>
-          <p:cNvPr id="13" name="TextBox 12"/>
+              <a:t>CIERRE DEL DEMO DAY · PROYECTO FINALISTA #1 DE MÉXICO · STELLAR × BAF</a:t>
+            </a:r>
+          </a:p>
+        </p:txBody>
+      </p:sp>
+      <p:sp>
+        <p:nvSpPr>
+          <p:cNvPr id="15" name="TextBox 14"/>
           <p:cNvSpPr txBox="1"/>
           <p:nvPr/>
         </p:nvSpPr>
         <p:spPr>
           <a:xfrm>
-            <a:off x="8686800" y="6291072"/>
+            <a:off x="8686800" y="6309360"/>
             <a:ext cx="2773375" cy="320040"/>
           </a:xfrm>
           <a:prstGeom prst="rect">
@@ -8985,7 +9722,7 @@
               </a:defRPr>
             </a:pPr>
             <a:r>
-              <a:t>4:00 - 4:30 (30 s)</a:t>
+              <a:t>5:00 - 7:00 (2:00 min)</a:t>
             </a:r>
           </a:p>
         </p:txBody>

</xml_diff>